<commit_message>
Fix Lesson 6 deck: add missing sim-gearing slide, tag code Try-It items
The doc's "Replace the last two drive-motor lines of simulatePeriodic()"
block (converting wheel-side sim motion back to rotor-side for the fake
encoder) was folded into a caption sentence instead of shown as code —
exactly the Lesson 7 bug pattern house rule #10 exists to prevent. Split
it onto its own slide. Also add the logTelemetry() DistanceMeters
addition, previously mentioned only in notes.

Tag all three Try-It items (reverse, ease-in with P control, watch both
endings) with the WRITE CODE pill in the deck and a bold Code lead-in in
the lesson doc, since all three involve writing real code, not just
running or observing something.
</commit_message>
<xml_diff>
--- a/docs/presentations/v3/06-distance-and-commands.pptx
+++ b/docs/presentations/v3/06-distance-and-commands.pptx
@@ -17,9 +17,10 @@
     <p:sldId id="265" r:id="rId11"/>
     <p:sldId id="266" r:id="rId12"/>
     <p:sldId id="267" r:id="rId13"/>
+    <p:sldId id="268" r:id="rId14"/>
   </p:sldIdLst>
   <p:notesMasterIdLst>
-    <p:notesMasterId r:id="rId14"/>
+    <p:notesMasterId r:id="rId15"/>
   </p:notesMasterIdLst>
   <p:sldSz cx="12191695" cy="6858000"/>
   <p:notesSz cx="6858000" cy="12191695"/>
@@ -601,7 +602,7 @@
           <a:p>
             <a:r>
               <a:rPr lang="en-US" dirty="0"/>
-              <a:t>dpadUp() is a new button family worth naming: the D-pad reports its four directions separately, and dpadUp() fires on the up direction — handy once the face buttons fill up, which they have by this point in the course. Worth mentioning as an aside, since this deck doesn't give it its own slide: with steerToAngle from Lesson 5 (point the wheel) and driveDistance now (roll it forward), students have the two ingredients for turning the robot — steer to an angle, then drive an arc length, sequenced with .andThen(...) (e.g. steerToAngle(90).andThen(driveDistance(1.0, 0.4)).named("Turn And Drive")). Lesson 7 builds the real four-module version and Lesson 8 does the clean gyro version, but the two bricks already exist to experiment with now.</a:t>
+              <a:t>Be precise here: .whenCanceled(() -&gt; m_driveMotor.setThrottle(0)) does NOT fire when the coroutine body finishes on its own — only when something else interrupts this command before it gets there, the same button-swap situation Lesson 5 already used it for. Every earlier command in this course only had one of these endings — driveAtSpeed and steerToAngle never finish on their own, so .whenCanceled(...) was the only ending that ever happened, and it was enough by itself. driveDistance is the first command that can end either way, which is why it's also the first one that needs cleanup written twice: once for "got there," inline in the body, and once for "got interrupted," in .whenCanceled(...). Miss either one and the motor keeps spinning in exactly that scenario — Lesson 1's rule, still true, just now with two doors it can sneak out of.</a:t>
             </a:r>
             <a:endParaRPr lang="en-US" dirty="0"/>
           </a:p>
@@ -689,7 +690,7 @@
           <a:p>
             <a:r>
               <a:rPr lang="en-US" dirty="0"/>
-              <a:t>The reverse exercise is a genuine bug students should hit before being told the fix: driveDistance(1.0, -0.4) never finishes because getDistanceMeters() &gt;= meters never becomes true — distance goes negative while meters stays positive. Wrapping both sides in Math.abs is the fix, and the point is explicitly "this is why you test edge cases," not just a syntax exercise. The ease-in exercise reuses Lesson 5's P control pattern on a new quantity — kP × (meters − getDistanceMeters()) — worth naming that this is the same control idea, just applied somewhere new. The watch-both-endings exercise is meant to be run for real, not just reasoned about: a print after waitUntil returns and a different print inside .whenCanceled(...), then tap D-pad up and let it finish, then tap again and interrupt it with a different button — exactly one print should appear each time, never both, confirming section 3's split by watching it happen.</a:t>
+              <a:t>dpadUp() is a new button family worth naming: the D-pad reports its four directions separately, and dpadUp() fires on the up direction — handy once the face buttons fill up, which they have by this point in the course. Worth mentioning as an aside, since this deck doesn't give it its own slide: with steerToAngle from Lesson 5 (point the wheel) and driveDistance now (roll it forward), students have the two ingredients for turning the robot — steer to an angle, then drive an arc length, sequenced with .andThen(...) (e.g. steerToAngle(90).andThen(driveDistance(1.0, 0.4)).named("Turn And Drive")). Lesson 7 builds the real four-module version and Lesson 8 does the clean gyro version, but the two bricks already exist to experiment with now.</a:t>
             </a:r>
             <a:endParaRPr lang="en-US" dirty="0"/>
           </a:p>
@@ -777,7 +778,7 @@
           <a:p>
             <a:r>
               <a:rPr lang="en-US" dirty="0"/>
-              <a:t>Two ideas carried this lesson. First: units are yours to build — gear ratio and wheel circumference turn rotor rotations into meters, setPosition(0) rezeros the encoder so distance means "since this command started," and named constants keep the conversion honest in one place. Second, and bigger: commands can finish, and in this framework that just means the coroutine body runs out of lines — no park(), no more code, done. The sharper edge underneath that: a command can end finished or canceled, they're genuinely different events, and only driveDistance has needed to handle both. That distinction is easy to miss and expensive to get wrong, so it's worth carrying forward deliberately. Lesson 7 turns the one module into four, and Lesson 9 strings finishing commands into a full autonomous routine. If the gearbox math felt dense, let the plot reassure you — when the trace stops at exactly 1.0 meters, every conversion in the chain earned its keep.</a:t>
+              <a:t>The reverse exercise is a genuine bug students should hit before being told the fix: driveDistance(1.0, -0.4) never finishes because getDistanceMeters() &gt;= meters never becomes true — distance goes negative while meters stays positive. Wrapping both sides in Math.abs is the fix, and the point is explicitly "this is why you test edge cases," not just a syntax exercise. The ease-in exercise reuses Lesson 5's P control pattern on a new quantity — kP × (meters − getDistanceMeters()) — worth naming that this is the same control idea, just applied somewhere new. The watch-both-endings exercise is meant to be run for real, not just reasoned about: a print after waitUntil returns and a different print inside .whenCanceled(...), then tap D-pad up and let it finish, then tap again and interrupt it with a different button — exactly one print should appear each time, never both, confirming section 3's split by watching it happen.</a:t>
             </a:r>
             <a:endParaRPr lang="en-US" dirty="0"/>
           </a:p>
@@ -801,6 +802,94 @@
             <a:fld id="{F7021451-1387-4CA6-816F-3879F97B5CBC}" type="slidenum">
               <a:rPr lang="en-US"/>
               <a:t>12</a:t>
+            </a:fld>
+            <a:endParaRPr lang="en-US"/>
+          </a:p>
+        </p:txBody>
+      </p:sp>
+    </p:spTree>
+    <p:extLst>
+      <p:ext uri="{BB962C8B-B14F-4D97-AF65-F5344CB8AC3E}">
+        <p14:creationId xmlns:p14="http://schemas.microsoft.com/office/powerpoint/2010/main" val="1024086991"/>
+      </p:ext>
+    </p:extLst>
+  </p:cSld>
+  <p:clrMapOvr>
+    <a:masterClrMapping/>
+  </p:clrMapOvr>
+</p:notes>
+</file>
+
+<file path=ppt/notesSlides/notesSlide13.xml><?xml version="1.0" encoding="utf-8"?>
+<p:notes xmlns:a="http://schemas.openxmlformats.org/drawingml/2006/main" xmlns:r="http://schemas.openxmlformats.org/officeDocument/2006/relationships" xmlns:p="http://schemas.openxmlformats.org/presentationml/2006/main">
+  <p:cSld>
+    <p:spTree>
+      <p:nvGrpSpPr>
+        <p:cNvPr id="1" name=""/>
+        <p:cNvGrpSpPr/>
+        <p:nvPr/>
+      </p:nvGrpSpPr>
+      <p:grpSpPr>
+        <a:xfrm>
+          <a:off x="0" y="0"/>
+          <a:ext cx="0" cy="0"/>
+          <a:chOff x="0" y="0"/>
+          <a:chExt cx="0" cy="0"/>
+        </a:xfrm>
+      </p:grpSpPr>
+      <p:sp>
+        <p:nvSpPr>
+          <p:cNvPr id="2" name="Slide Image Placeholder 1"/>
+          <p:cNvSpPr>
+            <a:spLocks noGrp="1" noRot="1" noChangeAspect="1"/>
+          </p:cNvSpPr>
+          <p:nvPr>
+            <p:ph type="sldImg"/>
+          </p:nvPr>
+        </p:nvSpPr>
+        <p:spPr/>
+      </p:sp>
+      <p:sp>
+        <p:nvSpPr>
+          <p:cNvPr id="3" name="Notes Placeholder 2"/>
+          <p:cNvSpPr>
+            <a:spLocks noGrp="1"/>
+          </p:cNvSpPr>
+          <p:nvPr>
+            <p:ph type="body" idx="1"/>
+          </p:nvPr>
+        </p:nvSpPr>
+        <p:spPr/>
+        <p:txBody>
+          <a:bodyPr/>
+          <a:lstStyle/>
+          <a:p>
+            <a:r>
+              <a:rPr lang="en-US" dirty="0"/>
+              <a:t>Two ideas carried this lesson. First: units are yours to build — gear ratio and wheel circumference turn rotor rotations into meters, setPosition(0) rezeros the encoder so distance means "since this command started," and named constants keep the conversion honest in one place. Second, and bigger: commands can finish, and in this framework that just means the coroutine body runs out of lines — no park(), no more code, done. The sharper edge underneath that: a command can end finished or canceled, they're genuinely different events, and only driveDistance has needed to handle both. That distinction is easy to miss and expensive to get wrong, so it's worth carrying forward deliberately. Lesson 7 turns the one module into four, and Lesson 9 strings finishing commands into a full autonomous routine. If the gearbox math felt dense, let the plot reassure you — when the trace stops at exactly 1.0 meters, every conversion in the chain earned its keep.</a:t>
+            </a:r>
+            <a:endParaRPr lang="en-US" dirty="0"/>
+          </a:p>
+        </p:txBody>
+      </p:sp>
+      <p:sp>
+        <p:nvSpPr>
+          <p:cNvPr id="4" name="Slide Number Placeholder 3"/>
+          <p:cNvSpPr>
+            <a:spLocks noGrp="1"/>
+          </p:cNvSpPr>
+          <p:nvPr>
+            <p:ph type="sldNum" sz="quarter" idx="10"/>
+          </p:nvPr>
+        </p:nvSpPr>
+        <p:spPr/>
+        <p:txBody>
+          <a:bodyPr/>
+          <a:lstStyle/>
+          <a:p>
+            <a:fld id="{F7021451-1387-4CA6-816F-3879F97B5CBC}" type="slidenum">
+              <a:rPr lang="en-US"/>
+              <a:t>13</a:t>
             </a:fld>
             <a:endParaRPr lang="en-US"/>
           </a:p>
@@ -1041,7 +1130,7 @@
           <a:p>
             <a:r>
               <a:rPr lang="en-US" dirty="0"/>
-              <a:t>This is why the constants get names instead of 6.75 sprinkled through the code: when you swap modules next season, you change one line in Constants.java and everything downstream is correct. Once this compiles, log it from the same place the other readings have been logging since Lesson 3 (DriveModule/DistanceMeters) — now there's a live odometer on the dashboard.</a:t>
+              <a:t>Read getDistanceMeters() as a pipeline: rotor turns ÷ gear ratio = wheel turns; wheel turns × circumference = meters. This is why the constants get names instead of 6.75 sprinkled through the code: when you swap modules next season, you change one line in Constants.java and everything downstream is correct. Log it from the same place the other readings have been logging since Lesson 3 — DriveModule/DistanceMeters joins the logs from Lessons 3 and 5 in logTelemetry() — and now there's a live odometer on the dashboard.</a:t>
             </a:r>
             <a:endParaRPr lang="en-US" dirty="0"/>
           </a:p>
@@ -1129,7 +1218,7 @@
           <a:p>
             <a:r>
               <a:rPr lang="en-US" dirty="0"/>
-              <a:t>Back in Lesson 4 the sim was built with gearing = 1.0 — a rotor spinning against a tiny inertia, no gearbox. Now that a real 6.75:1 reduction exists in the distance math, the sim has to learn about it too, or "one wheel turn" in sim won't mean the same physical motion as on the real robot. Two things changed: inertia grew from 0.001 to 0.025 (kg·m² at the wheel) — a rotor pulling a wheel through a gearbox has more to move than a bare rotor, and 0.025 gives a visible ramp without dragging; and gearing is now kDriveGearRatio instead of 1.0. The subtlety worth slowing down for: because DCMotorSim now models a gearbox, getAngularPosition/getAngularVelocity report the wheel (output) motion, not the rotor — but the TalonFX's fake encoder still lives on the rotor, since the sensor is physically on the motor, gearbox or not. So simulatePeriodic() has to convert wheel-side back to rotor-side by multiplying by the ratio, on top of the radians-to-rotations conversion from Lesson 4 which still has to happen too. If sim distances ever come out off by a suspiciously round factor, this chain — a gear ratio applied twice, or not at all — is the classic cause.</a:t>
+              <a:t>Back in Lesson 4 the sim was built with gearing = 1.0 — a rotor spinning against a tiny inertia, no gearbox. Now that a real 6.75:1 reduction exists in the distance math, the sim has to learn about it too, or "one wheel turn" in sim won't mean the same physical motion as on the real robot. Two things changed: inertia grew from 0.001 to 0.025 (kg·m² at the wheel) — a rotor pulling a wheel through a gearbox has more to move than a bare rotor, and 0.025 gives a visible ramp without dragging; and gearing is now kDriveGearRatio instead of 1.0.</a:t>
             </a:r>
             <a:endParaRPr lang="en-US" dirty="0"/>
           </a:p>
@@ -1217,7 +1306,7 @@
           <a:p>
             <a:r>
               <a:rPr lang="en-US" dirty="0"/>
-              <a:t>Stop and notice something about every command written so far: none of them ever finishes. driveAtSpeed parks forever; driveWithJoystick and steerToAngle recompute every tick, forever. They run until something else kills them — a button release, a rival command. That was fine for "spin while I hold a button," but "drive exactly one meter" is a different kind of job: the command itself is the only thing that knows when the job is done, so it has to decide for itself when to end. The idea is smaller than it sounds: a coroutine body is just code, top to bottom, like any method. driveAtSpeed's body never ends because it calls coroutine.park(), which means "suspend here forever." Leave that call out, and once the body's last line runs, the coroutine is done — same as a method returning — and the command finishes right along with it.</a:t>
+              <a:t>The subtlety worth slowing down for: because DCMotorSim now models a gearbox, getAngularPosition/getAngularVelocity report the wheel (output) motion, not the rotor — but the TalonFX's fake encoder still lives on the rotor, since the sensor is physically on the motor, gearbox or not. So simulatePeriodic() has to convert wheel-side back to rotor-side by multiplying by the ratio, on top of the radians-to-rotations conversion from Lesson 4 which still has to happen too. Now the whole chain is honest: applied volts spin the rotor, the wheel moves 1/6.75 as fast, getDistanceMeters() divides getPosition() by that same ratio, and the number of meters on the plot matches what the real robot would roll. If sim distances ever come out off by a suspiciously round factor, this chain — a gear ratio applied twice, or not at all — is the classic cause.</a:t>
             </a:r>
             <a:endParaRPr lang="en-US" dirty="0"/>
           </a:p>
@@ -1305,7 +1394,7 @@
           <a:p>
             <a:r>
               <a:rPr lang="en-US" dirty="0"/>
-              <a:t>Read it top to bottom as four steps. 1: m_driveMotor.setPosition(0) tells the encoder "call right here zero," so getDistanceMeters() measures from the start of this command, not since boot. 2: setThrottle(speed) starts the wheel moving, once. 3: coroutine.waitUntil(condition) is new — it suspends the command right here, checking the condition every tick, and only lets execution continue once it's true; the condition is a lambda answering true or false, the same trick as Lesson 2's DoubleSupplier but yes/no instead of a number. 4: once waitUntil returns, the distance check is true, so the next line stops the motor — then the lambda has nothing left to do, falls off the end, and the coroutine (and command) is done. One method, four lines, and it sets up, works, waits for done, and cleans up — no separate decorators needed, because it's just code running in order. This is the shape students will write constantly from here on.</a:t>
+              <a:t>Stop and notice something about every command written so far: none of them ever finishes. driveAtSpeed parks forever; driveWithJoystick and steerToAngle recompute every tick, forever. They run until something else kills them — a button release, a rival command. That was fine for "spin while I hold a button," but "drive exactly one meter" is a different kind of job: the command itself is the only thing that knows when the job is done, so it has to decide for itself when to end. The idea is smaller than it sounds: a coroutine body is just code, top to bottom, like any method. driveAtSpeed's body never ends because it calls coroutine.park(), which means "suspend here forever." Leave that call out, and once the body's last line runs, the coroutine is done — same as a method returning — and the command finishes right along with it.</a:t>
             </a:r>
             <a:endParaRPr lang="en-US" dirty="0"/>
           </a:p>
@@ -1393,7 +1482,7 @@
           <a:p>
             <a:r>
               <a:rPr lang="en-US" dirty="0"/>
-              <a:t>Notice there's no new decorator here at all — run(...), .whenCanceled(...), .named(...) are all things already had from Lesson 1. What's new is entirely inside the lambda: a while-shaped wait (waitUntil) sitting between two motor commands, in a body that's allowed to just... end. That's the payoff of a coroutine body: "do this, then wait, then do that" IS Java's normal control flow, not something bolted on with chained decorators.</a:t>
+              <a:t>Read it top to bottom as four steps. 1: m_driveMotor.setPosition(0) tells the encoder "call right here zero," so getDistanceMeters() measures from the start of this command, not since boot. 2: setThrottle(speed) starts the wheel moving, once. 3: coroutine.waitUntil(condition) is new — it suspends the command right here, checking the condition every tick, and only lets execution continue once it's true; the condition is a lambda answering true or false, the same trick as Lesson 2's DoubleSupplier but yes/no instead of a number. 4: once waitUntil returns, the distance check is true, so the next line stops the motor — then the lambda has nothing left to do, falls off the end, and the coroutine (and command) is done. One method, four lines, and it sets up, works, waits for done, and cleans up — no separate decorators needed, because it's just code running in order. This is the shape students will write constantly from here on.</a:t>
             </a:r>
             <a:endParaRPr lang="en-US" dirty="0"/>
           </a:p>
@@ -1481,7 +1570,7 @@
           <a:p>
             <a:r>
               <a:rPr lang="en-US" dirty="0"/>
-              <a:t>Be precise here: .whenCanceled(() -&gt; m_driveMotor.setThrottle(0)) does NOT fire when the coroutine body finishes on its own — only when something else interrupts this command before it gets there, the same button-swap situation Lesson 5 already used it for. Every earlier command in this course only had one of these endings — driveAtSpeed and steerToAngle never finish on their own, so .whenCanceled(...) was the only ending that ever happened, and it was enough by itself. driveDistance is the first command that can end either way, which is why it's also the first one that needs cleanup written twice: once for "got there," inline in the body, and once for "got interrupted," in .whenCanceled(...). Miss either one and the motor keeps spinning in exactly that scenario — Lesson 1's rule, still true, just now with two doors it can sneak out of.</a:t>
+              <a:t>Notice there's no new decorator here at all — run(...), .whenCanceled(...), .named(...) are all things already had from Lesson 1. What's new is entirely inside the lambda: a while-shaped wait (waitUntil) sitting between two motor commands, in a body that's allowed to just... end. That's the payoff of a coroutine body: "do this, then wait, then do that" IS Java's normal control flow, not something bolted on with chained decorators.</a:t>
             </a:r>
             <a:endParaRPr lang="en-US" dirty="0"/>
           </a:p>
@@ -2087,6 +2176,510 @@
     <p:bg>
       <p:bgPr>
         <a:solidFill>
+          <a:srgbClr val="0B1F3A"/>
+        </a:solidFill>
+      </p:bgPr>
+    </p:bg>
+    <p:spTree>
+      <p:nvGrpSpPr>
+        <p:cNvPr id="1" name=""/>
+        <p:cNvGrpSpPr/>
+        <p:nvPr/>
+      </p:nvGrpSpPr>
+      <p:grpSpPr>
+        <a:xfrm>
+          <a:off x="0" y="0"/>
+          <a:ext cx="0" cy="0"/>
+          <a:chOff x="0" y="0"/>
+          <a:chExt cx="0" cy="0"/>
+        </a:xfrm>
+      </p:grpSpPr>
+      <p:sp>
+        <p:nvSpPr>
+          <p:cNvPr id="2" name="Shape 0"/>
+          <p:cNvSpPr/>
+          <p:nvPr/>
+        </p:nvSpPr>
+        <p:spPr>
+          <a:xfrm>
+            <a:off x="640080" y="457200"/>
+            <a:ext cx="566928" cy="566928"/>
+          </a:xfrm>
+          <a:prstGeom prst="ellipse">
+            <a:avLst/>
+          </a:prstGeom>
+          <a:solidFill>
+            <a:srgbClr val="FF5010"/>
+          </a:solidFill>
+          <a:ln/>
+        </p:spPr>
+      </p:sp>
+      <p:pic>
+        <p:nvPicPr>
+          <p:cNvPr id="3" name="Image 0" descr="/home/user/BasicRobotLessons/docs/presentations/v3/template/assets/icons/checkcircle_white.png">    </p:cNvPr>
+          <p:cNvPicPr>
+            <a:picLocks noChangeAspect="1"/>
+          </p:cNvPicPr>
+          <p:nvPr/>
+        </p:nvPicPr>
+        <p:blipFill>
+          <a:blip r:embed="rId1"/>
+          <a:stretch>
+            <a:fillRect/>
+          </a:stretch>
+        </p:blipFill>
+        <p:spPr>
+          <a:xfrm>
+            <a:off x="768096" y="585216"/>
+            <a:ext cx="310896" cy="310896"/>
+          </a:xfrm>
+          <a:prstGeom prst="rect">
+            <a:avLst/>
+          </a:prstGeom>
+        </p:spPr>
+      </p:pic>
+      <p:sp>
+        <p:nvSpPr>
+          <p:cNvPr id="4" name="Text 1"/>
+          <p:cNvSpPr/>
+          <p:nvPr/>
+        </p:nvSpPr>
+        <p:spPr>
+          <a:xfrm>
+            <a:off x="1389888" y="402336"/>
+            <a:ext cx="9144000" cy="365760"/>
+          </a:xfrm>
+          <a:prstGeom prst="rect">
+            <a:avLst/>
+          </a:prstGeom>
+          <a:noFill/>
+          <a:ln/>
+        </p:spPr>
+        <p:txBody>
+          <a:bodyPr wrap="square" lIns="0" tIns="0" rIns="0" bIns="0" rtlCol="0" anchor="ctr"/>
+          <a:lstStyle/>
+          <a:p>
+            <a:pPr indent="0" marL="0">
+              <a:buNone/>
+            </a:pPr>
+            <a:r>
+              <a:rPr lang="en-US" sz="2000" b="1" spc="100" kern="0" dirty="0">
+                <a:solidFill>
+                  <a:srgbClr val="1B9AAA"/>
+                </a:solidFill>
+                <a:latin typeface="Calibri" pitchFamily="34" charset="0"/>
+                <a:ea typeface="Calibri" pitchFamily="34" charset="-122"/>
+                <a:cs typeface="Calibri" pitchFamily="34" charset="-120"/>
+              </a:rPr>
+              <a:t>SECTION 3 · TWO DIFFERENT ENDINGS</a:t>
+            </a:r>
+            <a:endParaRPr lang="en-US" sz="2000" dirty="0"/>
+          </a:p>
+        </p:txBody>
+      </p:sp>
+      <p:sp>
+        <p:nvSpPr>
+          <p:cNvPr id="5" name="Text 2"/>
+          <p:cNvSpPr/>
+          <p:nvPr/>
+        </p:nvSpPr>
+        <p:spPr>
+          <a:xfrm>
+            <a:off x="1371600" y="749808"/>
+            <a:ext cx="9418320" cy="594360"/>
+          </a:xfrm>
+          <a:prstGeom prst="rect">
+            <a:avLst/>
+          </a:prstGeom>
+          <a:noFill/>
+          <a:ln/>
+        </p:spPr>
+        <p:txBody>
+          <a:bodyPr wrap="square" lIns="0" tIns="0" rIns="0" bIns="0" rtlCol="0" anchor="ctr"/>
+          <a:lstStyle/>
+          <a:p>
+            <a:pPr indent="0" marL="0">
+              <a:buNone/>
+            </a:pPr>
+            <a:r>
+              <a:rPr lang="en-US" sz="3000" b="1" dirty="0">
+                <a:solidFill>
+                  <a:srgbClr val="FFFFFF"/>
+                </a:solidFill>
+                <a:latin typeface="Cambria" pitchFamily="34" charset="0"/>
+                <a:ea typeface="Cambria" pitchFamily="34" charset="-122"/>
+                <a:cs typeface="Cambria" pitchFamily="34" charset="-120"/>
+              </a:rPr>
+              <a:t>Finished and canceled are genuinely different events</a:t>
+            </a:r>
+            <a:endParaRPr lang="en-US" sz="3000" dirty="0"/>
+          </a:p>
+        </p:txBody>
+      </p:sp>
+      <p:sp>
+        <p:nvSpPr>
+          <p:cNvPr id="6" name="Shape 3"/>
+          <p:cNvSpPr/>
+          <p:nvPr/>
+        </p:nvSpPr>
+        <p:spPr>
+          <a:xfrm>
+            <a:off x="640080" y="1691640"/>
+            <a:ext cx="5349240" cy="3291840"/>
+          </a:xfrm>
+          <a:prstGeom prst="roundRect">
+            <a:avLst>
+              <a:gd name="adj" fmla="val 3333"/>
+            </a:avLst>
+          </a:prstGeom>
+          <a:solidFill>
+            <a:srgbClr val="132A4C"/>
+          </a:solidFill>
+          <a:ln/>
+        </p:spPr>
+      </p:sp>
+      <p:sp>
+        <p:nvSpPr>
+          <p:cNvPr id="7" name="Text 4"/>
+          <p:cNvSpPr/>
+          <p:nvPr/>
+        </p:nvSpPr>
+        <p:spPr>
+          <a:xfrm>
+            <a:off x="914400" y="1965960"/>
+            <a:ext cx="4800600" cy="548640"/>
+          </a:xfrm>
+          <a:prstGeom prst="rect">
+            <a:avLst/>
+          </a:prstGeom>
+          <a:noFill/>
+          <a:ln/>
+        </p:spPr>
+        <p:txBody>
+          <a:bodyPr wrap="square" lIns="0" tIns="0" rIns="0" bIns="0" rtlCol="0" anchor="ctr"/>
+          <a:lstStyle/>
+          <a:p>
+            <a:pPr indent="0" marL="0">
+              <a:buNone/>
+            </a:pPr>
+            <a:r>
+              <a:rPr lang="en-US" sz="2600" b="1" dirty="0">
+                <a:solidFill>
+                  <a:srgbClr val="FF5010"/>
+                </a:solidFill>
+                <a:latin typeface="Cambria" pitchFamily="34" charset="0"/>
+                <a:ea typeface="Cambria" pitchFamily="34" charset="-122"/>
+                <a:cs typeface="Cambria" pitchFamily="34" charset="-120"/>
+              </a:rPr>
+              <a:t>Finished</a:t>
+            </a:r>
+            <a:endParaRPr lang="en-US" sz="2600" dirty="0"/>
+          </a:p>
+        </p:txBody>
+      </p:sp>
+      <p:sp>
+        <p:nvSpPr>
+          <p:cNvPr id="8" name="Text 5"/>
+          <p:cNvSpPr/>
+          <p:nvPr/>
+        </p:nvSpPr>
+        <p:spPr>
+          <a:xfrm>
+            <a:off x="914400" y="2606040"/>
+            <a:ext cx="4800600" cy="2286000"/>
+          </a:xfrm>
+          <a:prstGeom prst="rect">
+            <a:avLst/>
+          </a:prstGeom>
+          <a:noFill/>
+          <a:ln/>
+        </p:spPr>
+        <p:txBody>
+          <a:bodyPr wrap="square" lIns="0" tIns="0" rIns="0" bIns="0" rtlCol="0" anchor="t"/>
+          <a:lstStyle/>
+          <a:p>
+            <a:pPr indent="0" marL="0">
+              <a:lnSpc>
+                <a:spcPct val="125000"/>
+              </a:lnSpc>
+              <a:buNone/>
+            </a:pPr>
+            <a:r>
+              <a:rPr lang="en-US" sz="2000" dirty="0">
+                <a:solidFill>
+                  <a:srgbClr val="D7E3F4"/>
+                </a:solidFill>
+                <a:latin typeface="Calibri" pitchFamily="34" charset="0"/>
+                <a:ea typeface="Calibri" pitchFamily="34" charset="-122"/>
+                <a:cs typeface="Calibri" pitchFamily="34" charset="-120"/>
+              </a:rPr>
+              <a:t>The body ran to the end by itself. Line 4, setThrottle(0), already handled it.</a:t>
+            </a:r>
+            <a:endParaRPr lang="en-US" sz="2000" dirty="0"/>
+          </a:p>
+        </p:txBody>
+      </p:sp>
+      <p:sp>
+        <p:nvSpPr>
+          <p:cNvPr id="9" name="Shape 6"/>
+          <p:cNvSpPr/>
+          <p:nvPr/>
+        </p:nvSpPr>
+        <p:spPr>
+          <a:xfrm>
+            <a:off x="6172200" y="1691640"/>
+            <a:ext cx="5349240" cy="3291840"/>
+          </a:xfrm>
+          <a:prstGeom prst="roundRect">
+            <a:avLst>
+              <a:gd name="adj" fmla="val 3333"/>
+            </a:avLst>
+          </a:prstGeom>
+          <a:solidFill>
+            <a:srgbClr val="132A4C"/>
+          </a:solidFill>
+          <a:ln/>
+        </p:spPr>
+      </p:sp>
+      <p:sp>
+        <p:nvSpPr>
+          <p:cNvPr id="10" name="Text 7"/>
+          <p:cNvSpPr/>
+          <p:nvPr/>
+        </p:nvSpPr>
+        <p:spPr>
+          <a:xfrm>
+            <a:off x="6446520" y="1965960"/>
+            <a:ext cx="4800600" cy="548640"/>
+          </a:xfrm>
+          <a:prstGeom prst="rect">
+            <a:avLst/>
+          </a:prstGeom>
+          <a:noFill/>
+          <a:ln/>
+        </p:spPr>
+        <p:txBody>
+          <a:bodyPr wrap="square" lIns="0" tIns="0" rIns="0" bIns="0" rtlCol="0" anchor="ctr"/>
+          <a:lstStyle/>
+          <a:p>
+            <a:pPr indent="0" marL="0">
+              <a:buNone/>
+            </a:pPr>
+            <a:r>
+              <a:rPr lang="en-US" sz="2600" b="1" dirty="0">
+                <a:solidFill>
+                  <a:srgbClr val="FF5010"/>
+                </a:solidFill>
+                <a:latin typeface="Cambria" pitchFamily="34" charset="0"/>
+                <a:ea typeface="Cambria" pitchFamily="34" charset="-122"/>
+                <a:cs typeface="Cambria" pitchFamily="34" charset="-120"/>
+              </a:rPr>
+              <a:t>Canceled</a:t>
+            </a:r>
+            <a:endParaRPr lang="en-US" sz="2600" dirty="0"/>
+          </a:p>
+        </p:txBody>
+      </p:sp>
+      <p:sp>
+        <p:nvSpPr>
+          <p:cNvPr id="11" name="Text 8"/>
+          <p:cNvSpPr/>
+          <p:nvPr/>
+        </p:nvSpPr>
+        <p:spPr>
+          <a:xfrm>
+            <a:off x="6446520" y="2606040"/>
+            <a:ext cx="4800600" cy="2286000"/>
+          </a:xfrm>
+          <a:prstGeom prst="rect">
+            <a:avLst/>
+          </a:prstGeom>
+          <a:noFill/>
+          <a:ln/>
+        </p:spPr>
+        <p:txBody>
+          <a:bodyPr wrap="square" lIns="0" tIns="0" rIns="0" bIns="0" rtlCol="0" anchor="t"/>
+          <a:lstStyle/>
+          <a:p>
+            <a:pPr indent="0" marL="0">
+              <a:lnSpc>
+                <a:spcPct val="125000"/>
+              </a:lnSpc>
+              <a:buNone/>
+            </a:pPr>
+            <a:r>
+              <a:rPr lang="en-US" sz="2000" dirty="0">
+                <a:solidFill>
+                  <a:srgbClr val="D7E3F4"/>
+                </a:solidFill>
+                <a:latin typeface="Calibri" pitchFamily="34" charset="0"/>
+                <a:ea typeface="Calibri" pitchFamily="34" charset="-122"/>
+                <a:cs typeface="Calibri" pitchFamily="34" charset="-120"/>
+              </a:rPr>
+              <a:t>Something else took the module away first — the body's own line 4 never gets to run. That's what .whenCanceled(...) is for.</a:t>
+            </a:r>
+            <a:endParaRPr lang="en-US" sz="2000" dirty="0"/>
+          </a:p>
+        </p:txBody>
+      </p:sp>
+      <p:sp>
+        <p:nvSpPr>
+          <p:cNvPr id="12" name="Text 9"/>
+          <p:cNvSpPr/>
+          <p:nvPr/>
+        </p:nvSpPr>
+        <p:spPr>
+          <a:xfrm>
+            <a:off x="640080" y="5166360"/>
+            <a:ext cx="10881360" cy="1051560"/>
+          </a:xfrm>
+          <a:prstGeom prst="rect">
+            <a:avLst/>
+          </a:prstGeom>
+          <a:noFill/>
+          <a:ln/>
+        </p:spPr>
+        <p:txBody>
+          <a:bodyPr wrap="square" lIns="0" tIns="0" rIns="0" bIns="0" rtlCol="0" anchor="t"/>
+          <a:lstStyle/>
+          <a:p>
+            <a:pPr indent="0" marL="0">
+              <a:lnSpc>
+                <a:spcPct val="125000"/>
+              </a:lnSpc>
+              <a:buNone/>
+            </a:pPr>
+            <a:r>
+              <a:rPr lang="en-US" sz="2000" i="1" dirty="0">
+                <a:solidFill>
+                  <a:srgbClr val="CADCE8"/>
+                </a:solidFill>
+                <a:latin typeface="Cambria" pitchFamily="34" charset="0"/>
+                <a:ea typeface="Cambria" pitchFamily="34" charset="-122"/>
+                <a:cs typeface="Cambria" pitchFamily="34" charset="-120"/>
+              </a:rPr>
+              <a:t>Every earlier command only had one ending. driveDistance is the first with two doors the motor can sneak out of — miss either cleanup, and it keeps spinning.</a:t>
+            </a:r>
+            <a:endParaRPr lang="en-US" sz="2000" dirty="0"/>
+          </a:p>
+        </p:txBody>
+      </p:sp>
+      <p:sp>
+        <p:nvSpPr>
+          <p:cNvPr id="13" name="Text 10"/>
+          <p:cNvSpPr/>
+          <p:nvPr/>
+        </p:nvSpPr>
+        <p:spPr>
+          <a:xfrm>
+            <a:off x="640080" y="6446520"/>
+            <a:ext cx="8229600" cy="365760"/>
+          </a:xfrm>
+          <a:prstGeom prst="rect">
+            <a:avLst/>
+          </a:prstGeom>
+          <a:noFill/>
+          <a:ln/>
+        </p:spPr>
+        <p:txBody>
+          <a:bodyPr wrap="square" lIns="0" tIns="0" rIns="0" bIns="0" rtlCol="0" anchor="ctr"/>
+          <a:lstStyle/>
+          <a:p>
+            <a:pPr indent="0" marL="0">
+              <a:buNone/>
+            </a:pPr>
+            <a:r>
+              <a:rPr lang="en-US" sz="2000" spc="100" kern="0" dirty="0">
+                <a:solidFill>
+                  <a:srgbClr val="7A93B8"/>
+                </a:solidFill>
+                <a:latin typeface="Calibri" pitchFamily="34" charset="0"/>
+                <a:ea typeface="Calibri" pitchFamily="34" charset="-122"/>
+                <a:cs typeface="Calibri" pitchFamily="34" charset="-120"/>
+              </a:rPr>
+              <a:t>LEARN JAVA + ROBOT PROGRAMMING · DISTANCE &amp; COMMANDS</a:t>
+            </a:r>
+            <a:endParaRPr lang="en-US" sz="2000" dirty="0"/>
+          </a:p>
+        </p:txBody>
+      </p:sp>
+      <p:sp>
+        <p:nvSpPr>
+          <p:cNvPr id="14" name="Text 11"/>
+          <p:cNvSpPr/>
+          <p:nvPr/>
+        </p:nvSpPr>
+        <p:spPr>
+          <a:xfrm>
+            <a:off x="11002975" y="6446520"/>
+            <a:ext cx="548640" cy="365760"/>
+          </a:xfrm>
+          <a:prstGeom prst="rect">
+            <a:avLst/>
+          </a:prstGeom>
+          <a:noFill/>
+          <a:ln/>
+        </p:spPr>
+        <p:txBody>
+          <a:bodyPr wrap="square" lIns="0" tIns="0" rIns="0" bIns="0" rtlCol="0" anchor="ctr"/>
+          <a:lstStyle/>
+          <a:p>
+            <a:pPr algn="r" indent="0" marL="0">
+              <a:buNone/>
+            </a:pPr>
+            <a:r>
+              <a:rPr lang="en-US" sz="2000" dirty="0">
+                <a:solidFill>
+                  <a:srgbClr val="7A93B8"/>
+                </a:solidFill>
+                <a:latin typeface="Calibri" pitchFamily="34" charset="0"/>
+                <a:ea typeface="Calibri" pitchFamily="34" charset="-122"/>
+                <a:cs typeface="Calibri" pitchFamily="34" charset="-120"/>
+              </a:rPr>
+              <a:t>10</a:t>
+            </a:r>
+            <a:endParaRPr lang="en-US" sz="2000" dirty="0"/>
+          </a:p>
+        </p:txBody>
+      </p:sp>
+      <p:pic>
+        <p:nvPicPr>
+          <p:cNvPr id="15" name="Image 1" descr="/home/user/BasicRobotLessons/docs/presentations/v3/template/assets/logo/team5010-logo-onnavy.png">    </p:cNvPr>
+          <p:cNvPicPr>
+            <a:picLocks noChangeAspect="1"/>
+          </p:cNvPicPr>
+          <p:nvPr/>
+        </p:nvPicPr>
+        <p:blipFill>
+          <a:blip r:embed="rId2"/>
+          <a:stretch>
+            <a:fillRect/>
+          </a:stretch>
+        </p:blipFill>
+        <p:spPr>
+          <a:xfrm>
+            <a:off x="10957255" y="164592"/>
+            <a:ext cx="777240" cy="605859"/>
+          </a:xfrm>
+          <a:prstGeom prst="rect">
+            <a:avLst/>
+          </a:prstGeom>
+        </p:spPr>
+      </p:pic>
+    </p:spTree>
+  </p:cSld>
+  <p:clrMapOvr>
+    <a:masterClrMapping/>
+  </p:clrMapOvr>
+</p:sld>
+</file>
+
+<file path=ppt/slides/slide11.xml><?xml version="1.0" encoding="utf-8"?>
+<p:sld xmlns:a="http://schemas.openxmlformats.org/drawingml/2006/main" xmlns:r="http://schemas.openxmlformats.org/officeDocument/2006/relationships" xmlns:p="http://schemas.openxmlformats.org/presentationml/2006/main">
+  <p:cSld name="Slide 11">
+    <p:bg>
+      <p:bgPr>
+        <a:solidFill>
           <a:srgbClr val="FFFFFF"/>
         </a:solidFill>
       </p:bgPr>
@@ -2595,7 +3188,7 @@
                 <a:ea typeface="Calibri" pitchFamily="34" charset="-122"/>
                 <a:cs typeface="Calibri" pitchFamily="34" charset="-120"/>
               </a:rPr>
-              <a:t>10</a:t>
+              <a:t>11</a:t>
             </a:r>
             <a:endParaRPr lang="en-US" sz="2000" dirty="0"/>
           </a:p>
@@ -2633,9 +3226,9 @@
 </p:sld>
 </file>
 
-<file path=ppt/slides/slide11.xml><?xml version="1.0" encoding="utf-8"?>
+<file path=ppt/slides/slide12.xml><?xml version="1.0" encoding="utf-8"?>
 <p:sld xmlns:a="http://schemas.openxmlformats.org/drawingml/2006/main" xmlns:r="http://schemas.openxmlformats.org/officeDocument/2006/relationships" xmlns:p="http://schemas.openxmlformats.org/presentationml/2006/main">
-  <p:cSld name="Slide 11">
+  <p:cSld name="Slide 12">
     <p:bg>
       <p:bgPr>
         <a:solidFill>
@@ -2869,7 +3462,7 @@
         <p:spPr>
           <a:xfrm>
             <a:off x="1600200" y="1691640"/>
-            <a:ext cx="4023360" cy="457200"/>
+            <a:ext cx="2606040" cy="457200"/>
           </a:xfrm>
           <a:prstGeom prst="rect">
             <a:avLst/>
@@ -2904,7 +3497,68 @@
       </p:sp>
       <p:sp>
         <p:nvSpPr>
-          <p:cNvPr id="10" name="Text 7"/>
+          <p:cNvPr id="10" name="Shape 7"/>
+          <p:cNvSpPr/>
+          <p:nvPr/>
+        </p:nvSpPr>
+        <p:spPr>
+          <a:xfrm>
+            <a:off x="4206240" y="1773936"/>
+            <a:ext cx="1417320" cy="292608"/>
+          </a:xfrm>
+          <a:prstGeom prst="roundRect">
+            <a:avLst>
+              <a:gd name="adj" fmla="val 18750"/>
+            </a:avLst>
+          </a:prstGeom>
+          <a:solidFill>
+            <a:srgbClr val="FF5010"/>
+          </a:solidFill>
+          <a:ln/>
+        </p:spPr>
+      </p:sp>
+      <p:sp>
+        <p:nvSpPr>
+          <p:cNvPr id="11" name="Text 8"/>
+          <p:cNvSpPr/>
+          <p:nvPr/>
+        </p:nvSpPr>
+        <p:spPr>
+          <a:xfrm>
+            <a:off x="4206240" y="1773936"/>
+            <a:ext cx="1417320" cy="292608"/>
+          </a:xfrm>
+          <a:prstGeom prst="rect">
+            <a:avLst/>
+          </a:prstGeom>
+          <a:noFill/>
+          <a:ln/>
+        </p:spPr>
+        <p:txBody>
+          <a:bodyPr wrap="square" lIns="0" tIns="0" rIns="0" bIns="0" rtlCol="0" anchor="ctr"/>
+          <a:lstStyle/>
+          <a:p>
+            <a:pPr algn="ctr" indent="0" marL="0">
+              <a:buNone/>
+            </a:pPr>
+            <a:r>
+              <a:rPr lang="en-US" sz="1200" b="1" spc="50" kern="0" dirty="0">
+                <a:solidFill>
+                  <a:srgbClr val="0B1F3A"/>
+                </a:solidFill>
+                <a:latin typeface="Calibri" pitchFamily="34" charset="0"/>
+                <a:ea typeface="Calibri" pitchFamily="34" charset="-122"/>
+                <a:cs typeface="Calibri" pitchFamily="34" charset="-120"/>
+              </a:rPr>
+              <a:t>WRITE CODE</a:t>
+            </a:r>
+            <a:endParaRPr lang="en-US" sz="1200" dirty="0"/>
+          </a:p>
+        </p:txBody>
+      </p:sp>
+      <p:sp>
+        <p:nvSpPr>
+          <p:cNvPr id="12" name="Text 9"/>
           <p:cNvSpPr/>
           <p:nvPr/>
         </p:nvSpPr>
@@ -2946,7 +3600,7 @@
       </p:sp>
       <p:sp>
         <p:nvSpPr>
-          <p:cNvPr id="11" name="Shape 8"/>
+          <p:cNvPr id="13" name="Shape 10"/>
           <p:cNvSpPr/>
           <p:nvPr/>
         </p:nvSpPr>
@@ -2968,7 +3622,7 @@
       </p:sp>
       <p:sp>
         <p:nvSpPr>
-          <p:cNvPr id="12" name="Shape 9"/>
+          <p:cNvPr id="14" name="Shape 11"/>
           <p:cNvSpPr/>
           <p:nvPr/>
         </p:nvSpPr>
@@ -2988,7 +3642,7 @@
       </p:sp>
       <p:sp>
         <p:nvSpPr>
-          <p:cNvPr id="13" name="Text 10"/>
+          <p:cNvPr id="15" name="Text 12"/>
           <p:cNvSpPr/>
           <p:nvPr/>
         </p:nvSpPr>
@@ -3027,14 +3681,14 @@
       </p:sp>
       <p:sp>
         <p:nvSpPr>
-          <p:cNvPr id="14" name="Text 11"/>
+          <p:cNvPr id="16" name="Text 13"/>
           <p:cNvSpPr/>
           <p:nvPr/>
         </p:nvSpPr>
         <p:spPr>
           <a:xfrm>
             <a:off x="7178040" y="1691640"/>
-            <a:ext cx="4023360" cy="457200"/>
+            <a:ext cx="2606040" cy="457200"/>
           </a:xfrm>
           <a:prstGeom prst="rect">
             <a:avLst/>
@@ -3069,7 +3723,68 @@
       </p:sp>
       <p:sp>
         <p:nvSpPr>
-          <p:cNvPr id="15" name="Text 12"/>
+          <p:cNvPr id="17" name="Shape 14"/>
+          <p:cNvSpPr/>
+          <p:nvPr/>
+        </p:nvSpPr>
+        <p:spPr>
+          <a:xfrm>
+            <a:off x="9784080" y="1773936"/>
+            <a:ext cx="1417320" cy="292608"/>
+          </a:xfrm>
+          <a:prstGeom prst="roundRect">
+            <a:avLst>
+              <a:gd name="adj" fmla="val 18750"/>
+            </a:avLst>
+          </a:prstGeom>
+          <a:solidFill>
+            <a:srgbClr val="FF5010"/>
+          </a:solidFill>
+          <a:ln/>
+        </p:spPr>
+      </p:sp>
+      <p:sp>
+        <p:nvSpPr>
+          <p:cNvPr id="18" name="Text 15"/>
+          <p:cNvSpPr/>
+          <p:nvPr/>
+        </p:nvSpPr>
+        <p:spPr>
+          <a:xfrm>
+            <a:off x="9784080" y="1773936"/>
+            <a:ext cx="1417320" cy="292608"/>
+          </a:xfrm>
+          <a:prstGeom prst="rect">
+            <a:avLst/>
+          </a:prstGeom>
+          <a:noFill/>
+          <a:ln/>
+        </p:spPr>
+        <p:txBody>
+          <a:bodyPr wrap="square" lIns="0" tIns="0" rIns="0" bIns="0" rtlCol="0" anchor="ctr"/>
+          <a:lstStyle/>
+          <a:p>
+            <a:pPr algn="ctr" indent="0" marL="0">
+              <a:buNone/>
+            </a:pPr>
+            <a:r>
+              <a:rPr lang="en-US" sz="1200" b="1" spc="50" kern="0" dirty="0">
+                <a:solidFill>
+                  <a:srgbClr val="0B1F3A"/>
+                </a:solidFill>
+                <a:latin typeface="Calibri" pitchFamily="34" charset="0"/>
+                <a:ea typeface="Calibri" pitchFamily="34" charset="-122"/>
+                <a:cs typeface="Calibri" pitchFamily="34" charset="-120"/>
+              </a:rPr>
+              <a:t>WRITE CODE</a:t>
+            </a:r>
+            <a:endParaRPr lang="en-US" sz="1200" dirty="0"/>
+          </a:p>
+        </p:txBody>
+      </p:sp>
+      <p:sp>
+        <p:nvSpPr>
+          <p:cNvPr id="19" name="Text 16"/>
           <p:cNvSpPr/>
           <p:nvPr/>
         </p:nvSpPr>
@@ -3111,7 +3826,7 @@
       </p:sp>
       <p:sp>
         <p:nvSpPr>
-          <p:cNvPr id="16" name="Shape 13"/>
+          <p:cNvPr id="20" name="Shape 17"/>
           <p:cNvSpPr/>
           <p:nvPr/>
         </p:nvSpPr>
@@ -3133,7 +3848,7 @@
       </p:sp>
       <p:sp>
         <p:nvSpPr>
-          <p:cNvPr id="17" name="Shape 14"/>
+          <p:cNvPr id="21" name="Shape 18"/>
           <p:cNvSpPr/>
           <p:nvPr/>
         </p:nvSpPr>
@@ -3153,7 +3868,7 @@
       </p:sp>
       <p:sp>
         <p:nvSpPr>
-          <p:cNvPr id="18" name="Text 15"/>
+          <p:cNvPr id="22" name="Text 19"/>
           <p:cNvSpPr/>
           <p:nvPr/>
         </p:nvSpPr>
@@ -3192,14 +3907,14 @@
       </p:sp>
       <p:sp>
         <p:nvSpPr>
-          <p:cNvPr id="19" name="Text 16"/>
+          <p:cNvPr id="23" name="Text 20"/>
           <p:cNvSpPr/>
           <p:nvPr/>
         </p:nvSpPr>
         <p:spPr>
           <a:xfrm>
             <a:off x="1600200" y="4251960"/>
-            <a:ext cx="4023360" cy="457200"/>
+            <a:ext cx="2606040" cy="457200"/>
           </a:xfrm>
           <a:prstGeom prst="rect">
             <a:avLst/>
@@ -3234,7 +3949,68 @@
       </p:sp>
       <p:sp>
         <p:nvSpPr>
-          <p:cNvPr id="20" name="Text 17"/>
+          <p:cNvPr id="24" name="Shape 21"/>
+          <p:cNvSpPr/>
+          <p:nvPr/>
+        </p:nvSpPr>
+        <p:spPr>
+          <a:xfrm>
+            <a:off x="4206240" y="4334256"/>
+            <a:ext cx="1417320" cy="292608"/>
+          </a:xfrm>
+          <a:prstGeom prst="roundRect">
+            <a:avLst>
+              <a:gd name="adj" fmla="val 18750"/>
+            </a:avLst>
+          </a:prstGeom>
+          <a:solidFill>
+            <a:srgbClr val="FF5010"/>
+          </a:solidFill>
+          <a:ln/>
+        </p:spPr>
+      </p:sp>
+      <p:sp>
+        <p:nvSpPr>
+          <p:cNvPr id="25" name="Text 22"/>
+          <p:cNvSpPr/>
+          <p:nvPr/>
+        </p:nvSpPr>
+        <p:spPr>
+          <a:xfrm>
+            <a:off x="4206240" y="4334256"/>
+            <a:ext cx="1417320" cy="292608"/>
+          </a:xfrm>
+          <a:prstGeom prst="rect">
+            <a:avLst/>
+          </a:prstGeom>
+          <a:noFill/>
+          <a:ln/>
+        </p:spPr>
+        <p:txBody>
+          <a:bodyPr wrap="square" lIns="0" tIns="0" rIns="0" bIns="0" rtlCol="0" anchor="ctr"/>
+          <a:lstStyle/>
+          <a:p>
+            <a:pPr algn="ctr" indent="0" marL="0">
+              <a:buNone/>
+            </a:pPr>
+            <a:r>
+              <a:rPr lang="en-US" sz="1200" b="1" spc="50" kern="0" dirty="0">
+                <a:solidFill>
+                  <a:srgbClr val="0B1F3A"/>
+                </a:solidFill>
+                <a:latin typeface="Calibri" pitchFamily="34" charset="0"/>
+                <a:ea typeface="Calibri" pitchFamily="34" charset="-122"/>
+                <a:cs typeface="Calibri" pitchFamily="34" charset="-120"/>
+              </a:rPr>
+              <a:t>WRITE CODE</a:t>
+            </a:r>
+            <a:endParaRPr lang="en-US" sz="1200" dirty="0"/>
+          </a:p>
+        </p:txBody>
+      </p:sp>
+      <p:sp>
+        <p:nvSpPr>
+          <p:cNvPr id="26" name="Text 23"/>
           <p:cNvSpPr/>
           <p:nvPr/>
         </p:nvSpPr>
@@ -3276,7 +4052,7 @@
       </p:sp>
       <p:sp>
         <p:nvSpPr>
-          <p:cNvPr id="21" name="Text 18"/>
+          <p:cNvPr id="27" name="Text 24"/>
           <p:cNvSpPr/>
           <p:nvPr/>
         </p:nvSpPr>
@@ -3315,7 +4091,7 @@
       </p:sp>
       <p:sp>
         <p:nvSpPr>
-          <p:cNvPr id="22" name="Text 19"/>
+          <p:cNvPr id="28" name="Text 25"/>
           <p:cNvSpPr/>
           <p:nvPr/>
         </p:nvSpPr>
@@ -3346,7 +4122,7 @@
                 <a:ea typeface="Calibri" pitchFamily="34" charset="-122"/>
                 <a:cs typeface="Calibri" pitchFamily="34" charset="-120"/>
               </a:rPr>
-              <a:t>11</a:t>
+              <a:t>12</a:t>
             </a:r>
             <a:endParaRPr lang="en-US" sz="2000" dirty="0"/>
           </a:p>
@@ -3354,7 +4130,7 @@
       </p:sp>
       <p:pic>
         <p:nvPicPr>
-          <p:cNvPr id="23" name="Image 1" descr="/home/user/BasicRobotLessons/docs/presentations/v3/template/assets/logo/team5010-logo-onnavy.png">    </p:cNvPr>
+          <p:cNvPr id="29" name="Image 1" descr="/home/user/BasicRobotLessons/docs/presentations/v3/template/assets/logo/team5010-logo-onnavy.png">    </p:cNvPr>
           <p:cNvPicPr>
             <a:picLocks noChangeAspect="1"/>
           </p:cNvPicPr>
@@ -3384,9 +4160,9 @@
 </p:sld>
 </file>
 
-<file path=ppt/slides/slide12.xml><?xml version="1.0" encoding="utf-8"?>
+<file path=ppt/slides/slide13.xml><?xml version="1.0" encoding="utf-8"?>
 <p:sld xmlns:a="http://schemas.openxmlformats.org/drawingml/2006/main" xmlns:r="http://schemas.openxmlformats.org/officeDocument/2006/relationships" xmlns:p="http://schemas.openxmlformats.org/presentationml/2006/main">
-  <p:cSld name="Slide 12">
+  <p:cSld name="Slide 13">
     <p:bg>
       <p:bgPr>
         <a:solidFill>
@@ -3921,7 +4697,7 @@
                 <a:ea typeface="Calibri" pitchFamily="34" charset="-122"/>
                 <a:cs typeface="Calibri" pitchFamily="34" charset="-120"/>
               </a:rPr>
-              <a:t>12</a:t>
+              <a:t>13</a:t>
             </a:r>
             <a:endParaRPr lang="en-US" sz="2000" dirty="0"/>
           </a:p>
@@ -5426,12 +6202,12 @@
         </p:nvSpPr>
         <p:spPr>
           <a:xfrm>
-            <a:off x="640080" y="1600200"/>
-            <a:ext cx="10881360" cy="2377440"/>
+            <a:off x="640080" y="1463040"/>
+            <a:ext cx="10881360" cy="2286000"/>
           </a:xfrm>
           <a:prstGeom prst="roundRect">
             <a:avLst>
-              <a:gd name="adj" fmla="val 4615"/>
+              <a:gd name="adj" fmla="val 4800"/>
             </a:avLst>
           </a:prstGeom>
           <a:solidFill>
@@ -5455,7 +6231,7 @@
         </p:nvSpPr>
         <p:spPr>
           <a:xfrm>
-            <a:off x="11210544" y="1746504"/>
+            <a:off x="11210544" y="1609344"/>
             <a:ext cx="128016" cy="128016"/>
           </a:xfrm>
           <a:prstGeom prst="ellipse">
@@ -5475,7 +6251,7 @@
         </p:nvSpPr>
         <p:spPr>
           <a:xfrm>
-            <a:off x="11210544" y="1947672"/>
+            <a:off x="11210544" y="1810512"/>
             <a:ext cx="128016" cy="128016"/>
           </a:xfrm>
           <a:prstGeom prst="ellipse">
@@ -5495,7 +6271,7 @@
         </p:nvSpPr>
         <p:spPr>
           <a:xfrm>
-            <a:off x="11210544" y="2148840"/>
+            <a:off x="11210544" y="2011680"/>
             <a:ext cx="128016" cy="128016"/>
           </a:xfrm>
           <a:prstGeom prst="ellipse">
@@ -5515,7 +6291,7 @@
         </p:nvSpPr>
         <p:spPr>
           <a:xfrm>
-            <a:off x="914400" y="1728216"/>
+            <a:off x="914400" y="1591056"/>
             <a:ext cx="10195560" cy="292608"/>
           </a:xfrm>
           <a:prstGeom prst="rect">
@@ -5554,8 +6330,8 @@
         </p:nvSpPr>
         <p:spPr>
           <a:xfrm>
-            <a:off x="914400" y="2057400"/>
-            <a:ext cx="10195560" cy="1719072"/>
+            <a:off x="914400" y="1920240"/>
+            <a:ext cx="10195560" cy="1627632"/>
           </a:xfrm>
           <a:prstGeom prst="rect">
             <a:avLst/>
@@ -5574,7 +6350,7 @@
               <a:buNone/>
             </a:pPr>
             <a:r>
-              <a:rPr lang="en-US" sz="1500" dirty="0">
+              <a:rPr lang="en-US" sz="1400" dirty="0">
                 <a:solidFill>
                   <a:srgbClr val="7FA8C9"/>
                 </a:solidFill>
@@ -5584,7 +6360,7 @@
               </a:rPr>
               <a:t>/** How far this module's wheel has driven, in meters, since the last reset. */</a:t>
             </a:r>
-            <a:endParaRPr lang="en-US" sz="1500" dirty="0"/>
+            <a:endParaRPr lang="en-US" sz="1400" dirty="0"/>
           </a:p>
           <a:p>
             <a:pPr indent="0" marL="0">
@@ -5594,7 +6370,7 @@
               <a:buNone/>
             </a:pPr>
             <a:r>
-              <a:rPr lang="en-US" sz="1500" dirty="0">
+              <a:rPr lang="en-US" sz="1400" dirty="0">
                 <a:solidFill>
                   <a:srgbClr val="FFD166"/>
                 </a:solidFill>
@@ -5604,7 +6380,7 @@
               </a:rPr>
               <a:t>public double getDistanceMeters() {</a:t>
             </a:r>
-            <a:endParaRPr lang="en-US" sz="1500" dirty="0"/>
+            <a:endParaRPr lang="en-US" sz="1400" dirty="0"/>
           </a:p>
           <a:p>
             <a:pPr indent="0" marL="0">
@@ -5614,7 +6390,7 @@
               <a:buNone/>
             </a:pPr>
             <a:r>
-              <a:rPr lang="en-US" sz="1500" dirty="0">
+              <a:rPr lang="en-US" sz="1400" dirty="0">
                 <a:solidFill>
                   <a:srgbClr val="D7E3F4"/>
                 </a:solidFill>
@@ -5624,7 +6400,7 @@
               </a:rPr>
               <a:t>  double rotorRotations = m_driveMotor.getPosition().getValue().in(Rotations);</a:t>
             </a:r>
-            <a:endParaRPr lang="en-US" sz="1500" dirty="0"/>
+            <a:endParaRPr lang="en-US" sz="1400" dirty="0"/>
           </a:p>
           <a:p>
             <a:pPr indent="0" marL="0">
@@ -5634,7 +6410,7 @@
               <a:buNone/>
             </a:pPr>
             <a:r>
-              <a:rPr lang="en-US" sz="1500" dirty="0">
+              <a:rPr lang="en-US" sz="1400" dirty="0">
                 <a:solidFill>
                   <a:srgbClr val="D7E3F4"/>
                 </a:solidFill>
@@ -5644,7 +6420,7 @@
               </a:rPr>
               <a:t>  double wheelRotations = rotorRotations / DriveConstants.kDriveGearRatio;</a:t>
             </a:r>
-            <a:endParaRPr lang="en-US" sz="1500" dirty="0"/>
+            <a:endParaRPr lang="en-US" sz="1400" dirty="0"/>
           </a:p>
           <a:p>
             <a:pPr indent="0" marL="0">
@@ -5654,7 +6430,7 @@
               <a:buNone/>
             </a:pPr>
             <a:r>
-              <a:rPr lang="en-US" sz="1500" dirty="0">
+              <a:rPr lang="en-US" sz="1400" dirty="0">
                 <a:solidFill>
                   <a:srgbClr val="9EF01A"/>
                 </a:solidFill>
@@ -5664,7 +6440,7 @@
               </a:rPr>
               <a:t>  return wheelRotations * DriveConstants.kWheelCircumferenceMeters;</a:t>
             </a:r>
-            <a:endParaRPr lang="en-US" sz="1500" dirty="0"/>
+            <a:endParaRPr lang="en-US" sz="1400" dirty="0"/>
           </a:p>
           <a:p>
             <a:pPr indent="0" marL="0">
@@ -5674,7 +6450,7 @@
               <a:buNone/>
             </a:pPr>
             <a:r>
-              <a:rPr lang="en-US" sz="1500" dirty="0">
+              <a:rPr lang="en-US" sz="1400" dirty="0">
                 <a:solidFill>
                   <a:srgbClr val="D7E3F4"/>
                 </a:solidFill>
@@ -5684,7 +6460,7 @@
               </a:rPr>
               <a:t>}</a:t>
             </a:r>
-            <a:endParaRPr lang="en-US" sz="1500" dirty="0"/>
+            <a:endParaRPr lang="en-US" sz="1400" dirty="0"/>
           </a:p>
         </p:txBody>
       </p:sp>
@@ -5696,30 +6472,136 @@
         </p:nvSpPr>
         <p:spPr>
           <a:xfrm>
-            <a:off x="640080" y="4114800"/>
-            <a:ext cx="10881360" cy="2286000"/>
+            <a:off x="640080" y="3931920"/>
+            <a:ext cx="10881360" cy="2194560"/>
           </a:xfrm>
           <a:prstGeom prst="roundRect">
             <a:avLst>
-              <a:gd name="adj" fmla="val 4000"/>
+              <a:gd name="adj" fmla="val 5000"/>
             </a:avLst>
           </a:prstGeom>
           <a:solidFill>
-            <a:srgbClr val="F3F6FA"/>
+            <a:srgbClr val="0B1F3A"/>
           </a:solidFill>
           <a:ln/>
-        </p:spPr>
-      </p:sp>
-      <p:sp>
-        <p:nvSpPr>
-          <p:cNvPr id="13" name="Text 10"/>
+          <a:effectLst>
+            <a:outerShdw sx="100000" sy="100000" kx="0" ky="0" algn="bl" rotWithShape="0" blurRad="101600" dist="38100" dir="5400000">
+              <a:srgbClr val="0B1F3A">
+                <a:alpha val="35000"/>
+              </a:srgbClr>
+            </a:outerShdw>
+          </a:effectLst>
+        </p:spPr>
+      </p:sp>
+      <p:sp>
+        <p:nvSpPr>
+          <p:cNvPr id="13" name="Shape 10"/>
+          <p:cNvSpPr/>
+          <p:nvPr/>
+        </p:nvSpPr>
+        <p:spPr>
+          <a:xfrm>
+            <a:off x="11210544" y="4078224"/>
+            <a:ext cx="128016" cy="128016"/>
+          </a:xfrm>
+          <a:prstGeom prst="ellipse">
+            <a:avLst/>
+          </a:prstGeom>
+          <a:solidFill>
+            <a:srgbClr val="FF6B6B"/>
+          </a:solidFill>
+          <a:ln/>
+        </p:spPr>
+      </p:sp>
+      <p:sp>
+        <p:nvSpPr>
+          <p:cNvPr id="14" name="Shape 11"/>
+          <p:cNvSpPr/>
+          <p:nvPr/>
+        </p:nvSpPr>
+        <p:spPr>
+          <a:xfrm>
+            <a:off x="11210544" y="4279392"/>
+            <a:ext cx="128016" cy="128016"/>
+          </a:xfrm>
+          <a:prstGeom prst="ellipse">
+            <a:avLst/>
+          </a:prstGeom>
+          <a:solidFill>
+            <a:srgbClr val="FFD166"/>
+          </a:solidFill>
+          <a:ln/>
+        </p:spPr>
+      </p:sp>
+      <p:sp>
+        <p:nvSpPr>
+          <p:cNvPr id="15" name="Shape 12"/>
+          <p:cNvSpPr/>
+          <p:nvPr/>
+        </p:nvSpPr>
+        <p:spPr>
+          <a:xfrm>
+            <a:off x="11210544" y="4480560"/>
+            <a:ext cx="128016" cy="128016"/>
+          </a:xfrm>
+          <a:prstGeom prst="ellipse">
+            <a:avLst/>
+          </a:prstGeom>
+          <a:solidFill>
+            <a:srgbClr val="2EC4B6"/>
+          </a:solidFill>
+          <a:ln/>
+        </p:spPr>
+      </p:sp>
+      <p:sp>
+        <p:nvSpPr>
+          <p:cNvPr id="16" name="Text 13"/>
+          <p:cNvSpPr/>
+          <p:nvPr/>
+        </p:nvSpPr>
+        <p:spPr>
+          <a:xfrm>
+            <a:off x="914400" y="4059936"/>
+            <a:ext cx="10195560" cy="292608"/>
+          </a:xfrm>
+          <a:prstGeom prst="rect">
+            <a:avLst/>
+          </a:prstGeom>
+          <a:noFill/>
+          <a:ln/>
+        </p:spPr>
+        <p:txBody>
+          <a:bodyPr wrap="square" lIns="0" tIns="0" rIns="0" bIns="0" rtlCol="0" anchor="ctr"/>
+          <a:lstStyle/>
+          <a:p>
+            <a:pPr indent="0" marL="0">
+              <a:buNone/>
+            </a:pPr>
+            <a:r>
+              <a:rPr lang="en-US" sz="1500" b="1" dirty="0">
+                <a:solidFill>
+                  <a:srgbClr val="FF5010"/>
+                </a:solidFill>
+                <a:latin typeface="Calibri" pitchFamily="34" charset="0"/>
+                <a:ea typeface="Calibri" pitchFamily="34" charset="-122"/>
+                <a:cs typeface="Calibri" pitchFamily="34" charset="-120"/>
+              </a:rPr>
+              <a:t>Add to DriveModule's logTelemetry()</a:t>
+            </a:r>
+            <a:endParaRPr lang="en-US" sz="1500" dirty="0"/>
+          </a:p>
+        </p:txBody>
+      </p:sp>
+      <p:sp>
+        <p:nvSpPr>
+          <p:cNvPr id="17" name="Text 14"/>
           <p:cNvSpPr/>
           <p:nvPr/>
         </p:nvSpPr>
         <p:spPr>
           <a:xfrm>
             <a:off x="914400" y="4389120"/>
-            <a:ext cx="10332720" cy="577850"/>
+            <a:ext cx="10195560" cy="1536192"/>
           </a:xfrm>
           <a:prstGeom prst="rect">
             <a:avLst/>
@@ -5738,57 +6620,114 @@
               <a:buNone/>
             </a:pPr>
             <a:r>
-              <a:rPr lang="en-US" sz="2200" b="1" dirty="0">
-                <a:solidFill>
-                  <a:srgbClr val="13294B"/>
-                </a:solidFill>
-                <a:latin typeface="Cambria" pitchFamily="34" charset="0"/>
-                <a:ea typeface="Cambria" pitchFamily="34" charset="-122"/>
-                <a:cs typeface="Cambria" pitchFamily="34" charset="-120"/>
-              </a:rPr>
-              <a:t>Read it as a pipeline.</a:t>
-            </a:r>
-            <a:endParaRPr lang="en-US" sz="2200" dirty="0"/>
-          </a:p>
-        </p:txBody>
-      </p:sp>
-      <p:sp>
-        <p:nvSpPr>
-          <p:cNvPr id="14" name="Text 11"/>
-          <p:cNvSpPr/>
-          <p:nvPr/>
-        </p:nvSpPr>
-        <p:spPr>
-          <a:xfrm>
-            <a:off x="914400" y="4966970"/>
-            <a:ext cx="10332720" cy="1159510"/>
-          </a:xfrm>
-          <a:prstGeom prst="rect">
-            <a:avLst/>
-          </a:prstGeom>
-          <a:noFill/>
-          <a:ln/>
-        </p:spPr>
-        <p:txBody>
-          <a:bodyPr wrap="square" lIns="0" tIns="0" rIns="0" bIns="0" rtlCol="0" anchor="t"/>
-          <a:lstStyle/>
+              <a:rPr lang="en-US" sz="1600" dirty="0">
+                <a:solidFill>
+                  <a:srgbClr val="FFD166"/>
+                </a:solidFill>
+                <a:latin typeface="Courier New" pitchFamily="34" charset="0"/>
+                <a:ea typeface="Courier New" pitchFamily="34" charset="-122"/>
+                <a:cs typeface="Courier New" pitchFamily="34" charset="-120"/>
+              </a:rPr>
+              <a:t>private void logTelemetry() {</a:t>
+            </a:r>
+            <a:endParaRPr lang="en-US" sz="1600" dirty="0"/>
+          </a:p>
           <a:p>
             <a:pPr indent="0" marL="0">
               <a:lnSpc>
-                <a:spcPct val="125000"/>
+                <a:spcPct val="120000"/>
               </a:lnSpc>
               <a:buNone/>
             </a:pPr>
             <a:r>
-              <a:rPr lang="en-US" sz="2000" dirty="0">
-                <a:solidFill>
-                  <a:srgbClr val="13294B"/>
+              <a:rPr lang="en-US" sz="1600" dirty="0">
+                <a:solidFill>
+                  <a:srgbClr val="7FA8C9"/>
+                </a:solidFill>
+                <a:latin typeface="Courier New" pitchFamily="34" charset="0"/>
+                <a:ea typeface="Courier New" pitchFamily="34" charset="-122"/>
+                <a:cs typeface="Courier New" pitchFamily="34" charset="-120"/>
+              </a:rPr>
+              <a:t>  // ...the logs from Lessons 3 and 5 stay...</a:t>
+            </a:r>
+            <a:endParaRPr lang="en-US" sz="1600" dirty="0"/>
+          </a:p>
+          <a:p>
+            <a:pPr indent="0" marL="0">
+              <a:lnSpc>
+                <a:spcPct val="120000"/>
+              </a:lnSpc>
+              <a:buNone/>
+            </a:pPr>
+            <a:r>
+              <a:rPr lang="en-US" sz="1600" dirty="0">
+                <a:solidFill>
+                  <a:srgbClr val="9EF01A"/>
+                </a:solidFill>
+                <a:latin typeface="Courier New" pitchFamily="34" charset="0"/>
+                <a:ea typeface="Courier New" pitchFamily="34" charset="-122"/>
+                <a:cs typeface="Courier New" pitchFamily="34" charset="-120"/>
+              </a:rPr>
+              <a:t>  SmartDashboard.putNumber("DriveModule/DistanceMeters", getDistanceMeters());</a:t>
+            </a:r>
+            <a:endParaRPr lang="en-US" sz="1600" dirty="0"/>
+          </a:p>
+          <a:p>
+            <a:pPr indent="0" marL="0">
+              <a:lnSpc>
+                <a:spcPct val="120000"/>
+              </a:lnSpc>
+              <a:buNone/>
+            </a:pPr>
+            <a:r>
+              <a:rPr lang="en-US" sz="1600" dirty="0">
+                <a:solidFill>
+                  <a:srgbClr val="D7E3F4"/>
+                </a:solidFill>
+                <a:latin typeface="Courier New" pitchFamily="34" charset="0"/>
+                <a:ea typeface="Courier New" pitchFamily="34" charset="-122"/>
+                <a:cs typeface="Courier New" pitchFamily="34" charset="-120"/>
+              </a:rPr>
+              <a:t>}</a:t>
+            </a:r>
+            <a:endParaRPr lang="en-US" sz="1600" dirty="0"/>
+          </a:p>
+        </p:txBody>
+      </p:sp>
+      <p:sp>
+        <p:nvSpPr>
+          <p:cNvPr id="18" name="Text 15"/>
+          <p:cNvSpPr/>
+          <p:nvPr/>
+        </p:nvSpPr>
+        <p:spPr>
+          <a:xfrm>
+            <a:off x="640080" y="6446520"/>
+            <a:ext cx="8229600" cy="365760"/>
+          </a:xfrm>
+          <a:prstGeom prst="rect">
+            <a:avLst/>
+          </a:prstGeom>
+          <a:noFill/>
+          <a:ln/>
+        </p:spPr>
+        <p:txBody>
+          <a:bodyPr wrap="square" lIns="0" tIns="0" rIns="0" bIns="0" rtlCol="0" anchor="ctr"/>
+          <a:lstStyle/>
+          <a:p>
+            <a:pPr indent="0" marL="0">
+              <a:buNone/>
+            </a:pPr>
+            <a:r>
+              <a:rPr lang="en-US" sz="2000" spc="100" kern="0" dirty="0">
+                <a:solidFill>
+                  <a:srgbClr val="5B6B84"/>
                 </a:solidFill>
                 <a:latin typeface="Calibri" pitchFamily="34" charset="0"/>
                 <a:ea typeface="Calibri" pitchFamily="34" charset="-122"/>
                 <a:cs typeface="Calibri" pitchFamily="34" charset="-120"/>
               </a:rPr>
-              <a:t>Rotor turns ÷ gear ratio = wheel turns; wheel turns × circumference = meters. Name the constants, and swapping modules next season means changing one line in Constants.java.</a:t>
+              <a:t>LEARN JAVA + ROBOT PROGRAMMING · DISTANCE &amp; COMMANDS</a:t>
             </a:r>
             <a:endParaRPr lang="en-US" sz="2000" dirty="0"/>
           </a:p>
@@ -5796,14 +6735,14 @@
       </p:sp>
       <p:sp>
         <p:nvSpPr>
-          <p:cNvPr id="15" name="Text 12"/>
-          <p:cNvSpPr/>
-          <p:nvPr/>
-        </p:nvSpPr>
-        <p:spPr>
-          <a:xfrm>
-            <a:off x="640080" y="6446520"/>
-            <a:ext cx="8229600" cy="365760"/>
+          <p:cNvPr id="19" name="Text 16"/>
+          <p:cNvSpPr/>
+          <p:nvPr/>
+        </p:nvSpPr>
+        <p:spPr>
+          <a:xfrm>
+            <a:off x="11002975" y="6446520"/>
+            <a:ext cx="548640" cy="365760"/>
           </a:xfrm>
           <a:prstGeom prst="rect">
             <a:avLst/>
@@ -5815,11 +6754,11 @@
           <a:bodyPr wrap="square" lIns="0" tIns="0" rIns="0" bIns="0" rtlCol="0" anchor="ctr"/>
           <a:lstStyle/>
           <a:p>
-            <a:pPr indent="0" marL="0">
-              <a:buNone/>
-            </a:pPr>
-            <a:r>
-              <a:rPr lang="en-US" sz="2000" spc="100" kern="0" dirty="0">
+            <a:pPr algn="r" indent="0" marL="0">
+              <a:buNone/>
+            </a:pPr>
+            <a:r>
+              <a:rPr lang="en-US" sz="2000" dirty="0">
                 <a:solidFill>
                   <a:srgbClr val="5B6B84"/>
                 </a:solidFill>
@@ -5827,45 +6766,6 @@
                 <a:ea typeface="Calibri" pitchFamily="34" charset="-122"/>
                 <a:cs typeface="Calibri" pitchFamily="34" charset="-120"/>
               </a:rPr>
-              <a:t>LEARN JAVA + ROBOT PROGRAMMING · DISTANCE &amp; COMMANDS</a:t>
-            </a:r>
-            <a:endParaRPr lang="en-US" sz="2000" dirty="0"/>
-          </a:p>
-        </p:txBody>
-      </p:sp>
-      <p:sp>
-        <p:nvSpPr>
-          <p:cNvPr id="16" name="Text 13"/>
-          <p:cNvSpPr/>
-          <p:nvPr/>
-        </p:nvSpPr>
-        <p:spPr>
-          <a:xfrm>
-            <a:off x="11002975" y="6446520"/>
-            <a:ext cx="548640" cy="365760"/>
-          </a:xfrm>
-          <a:prstGeom prst="rect">
-            <a:avLst/>
-          </a:prstGeom>
-          <a:noFill/>
-          <a:ln/>
-        </p:spPr>
-        <p:txBody>
-          <a:bodyPr wrap="square" lIns="0" tIns="0" rIns="0" bIns="0" rtlCol="0" anchor="ctr"/>
-          <a:lstStyle/>
-          <a:p>
-            <a:pPr algn="r" indent="0" marL="0">
-              <a:buNone/>
-            </a:pPr>
-            <a:r>
-              <a:rPr lang="en-US" sz="2000" dirty="0">
-                <a:solidFill>
-                  <a:srgbClr val="5B6B84"/>
-                </a:solidFill>
-                <a:latin typeface="Calibri" pitchFamily="34" charset="0"/>
-                <a:ea typeface="Calibri" pitchFamily="34" charset="-122"/>
-                <a:cs typeface="Calibri" pitchFamily="34" charset="-120"/>
-              </a:rPr>
               <a:t>4</a:t>
             </a:r>
             <a:endParaRPr lang="en-US" sz="2000" dirty="0"/>
@@ -5874,7 +6774,7 @@
       </p:sp>
       <p:pic>
         <p:nvPicPr>
-          <p:cNvPr id="17" name="Image 1" descr="/home/user/BasicRobotLessons/docs/presentations/v3/template/assets/logo/team5010-logo-onwhite.png">    </p:cNvPr>
+          <p:cNvPr id="20" name="Image 1" descr="/home/user/BasicRobotLessons/docs/presentations/v3/template/assets/logo/team5010-logo-onwhite.png">    </p:cNvPr>
           <p:cNvPicPr>
             <a:picLocks noChangeAspect="1"/>
           </p:cNvPicPr>
@@ -6522,6 +7422,598 @@
     <p:bg>
       <p:bgPr>
         <a:solidFill>
+          <a:srgbClr val="FFFFFF"/>
+        </a:solidFill>
+      </p:bgPr>
+    </p:bg>
+    <p:spTree>
+      <p:nvGrpSpPr>
+        <p:cNvPr id="1" name=""/>
+        <p:cNvGrpSpPr/>
+        <p:nvPr/>
+      </p:nvGrpSpPr>
+      <p:grpSpPr>
+        <a:xfrm>
+          <a:off x="0" y="0"/>
+          <a:ext cx="0" cy="0"/>
+          <a:chOff x="0" y="0"/>
+          <a:chExt cx="0" cy="0"/>
+        </a:xfrm>
+      </p:grpSpPr>
+      <p:sp>
+        <p:nvSpPr>
+          <p:cNvPr id="2" name="Shape 0"/>
+          <p:cNvSpPr/>
+          <p:nvPr/>
+        </p:nvSpPr>
+        <p:spPr>
+          <a:xfrm>
+            <a:off x="640080" y="457200"/>
+            <a:ext cx="566928" cy="566928"/>
+          </a:xfrm>
+          <a:prstGeom prst="ellipse">
+            <a:avLst/>
+          </a:prstGeom>
+          <a:solidFill>
+            <a:srgbClr val="0B1F3A"/>
+          </a:solidFill>
+          <a:ln/>
+        </p:spPr>
+      </p:sp>
+      <p:pic>
+        <p:nvPicPr>
+          <p:cNvPr id="3" name="Image 0" descr="/home/user/BasicRobotLessons/docs/presentations/v3/template/assets/icons/syncalt_white.png">    </p:cNvPr>
+          <p:cNvPicPr>
+            <a:picLocks noChangeAspect="1"/>
+          </p:cNvPicPr>
+          <p:nvPr/>
+        </p:nvPicPr>
+        <p:blipFill>
+          <a:blip r:embed="rId1"/>
+          <a:stretch>
+            <a:fillRect/>
+          </a:stretch>
+        </p:blipFill>
+        <p:spPr>
+          <a:xfrm>
+            <a:off x="768096" y="585216"/>
+            <a:ext cx="310896" cy="310896"/>
+          </a:xfrm>
+          <a:prstGeom prst="rect">
+            <a:avLst/>
+          </a:prstGeom>
+        </p:spPr>
+      </p:pic>
+      <p:sp>
+        <p:nvSpPr>
+          <p:cNvPr id="4" name="Text 1"/>
+          <p:cNvSpPr/>
+          <p:nvPr/>
+        </p:nvSpPr>
+        <p:spPr>
+          <a:xfrm>
+            <a:off x="1389888" y="402336"/>
+            <a:ext cx="9144000" cy="365760"/>
+          </a:xfrm>
+          <a:prstGeom prst="rect">
+            <a:avLst/>
+          </a:prstGeom>
+          <a:noFill/>
+          <a:ln/>
+        </p:spPr>
+        <p:txBody>
+          <a:bodyPr wrap="square" lIns="0" tIns="0" rIns="0" bIns="0" rtlCol="0" anchor="ctr"/>
+          <a:lstStyle/>
+          <a:p>
+            <a:pPr indent="0" marL="0">
+              <a:buNone/>
+            </a:pPr>
+            <a:r>
+              <a:rPr lang="en-US" sz="2000" b="1" spc="150" kern="0" dirty="0">
+                <a:solidFill>
+                  <a:srgbClr val="FF5010"/>
+                </a:solidFill>
+                <a:latin typeface="Calibri" pitchFamily="34" charset="0"/>
+                <a:ea typeface="Calibri" pitchFamily="34" charset="-122"/>
+                <a:cs typeface="Calibri" pitchFamily="34" charset="-120"/>
+              </a:rPr>
+              <a:t>SECTION 2 CONTINUED · DRIVEMODULE.JAVA</a:t>
+            </a:r>
+            <a:endParaRPr lang="en-US" sz="2000" dirty="0"/>
+          </a:p>
+        </p:txBody>
+      </p:sp>
+      <p:sp>
+        <p:nvSpPr>
+          <p:cNvPr id="5" name="Text 2"/>
+          <p:cNvSpPr/>
+          <p:nvPr/>
+        </p:nvSpPr>
+        <p:spPr>
+          <a:xfrm>
+            <a:off x="1371600" y="749808"/>
+            <a:ext cx="9418320" cy="594360"/>
+          </a:xfrm>
+          <a:prstGeom prst="rect">
+            <a:avLst/>
+          </a:prstGeom>
+          <a:noFill/>
+          <a:ln/>
+        </p:spPr>
+        <p:txBody>
+          <a:bodyPr wrap="square" lIns="0" tIns="0" rIns="0" bIns="0" rtlCol="0" anchor="ctr"/>
+          <a:lstStyle/>
+          <a:p>
+            <a:pPr indent="0" marL="0">
+              <a:buNone/>
+            </a:pPr>
+            <a:r>
+              <a:rPr lang="en-US" sz="3000" b="1" dirty="0">
+                <a:solidFill>
+                  <a:srgbClr val="13294B"/>
+                </a:solidFill>
+                <a:latin typeface="Cambria" pitchFamily="34" charset="0"/>
+                <a:ea typeface="Cambria" pitchFamily="34" charset="-122"/>
+                <a:cs typeface="Cambria" pitchFamily="34" charset="-120"/>
+              </a:rPr>
+              <a:t>Convert wheel-side back to rotor-side</a:t>
+            </a:r>
+            <a:endParaRPr lang="en-US" sz="3000" dirty="0"/>
+          </a:p>
+        </p:txBody>
+      </p:sp>
+      <p:sp>
+        <p:nvSpPr>
+          <p:cNvPr id="6" name="Shape 3"/>
+          <p:cNvSpPr/>
+          <p:nvPr/>
+        </p:nvSpPr>
+        <p:spPr>
+          <a:xfrm>
+            <a:off x="640080" y="1600200"/>
+            <a:ext cx="10881360" cy="1828800"/>
+          </a:xfrm>
+          <a:prstGeom prst="roundRect">
+            <a:avLst>
+              <a:gd name="adj" fmla="val 6000"/>
+            </a:avLst>
+          </a:prstGeom>
+          <a:solidFill>
+            <a:srgbClr val="0B1F3A"/>
+          </a:solidFill>
+          <a:ln/>
+          <a:effectLst>
+            <a:outerShdw sx="100000" sy="100000" kx="0" ky="0" algn="bl" rotWithShape="0" blurRad="101600" dist="38100" dir="5400000">
+              <a:srgbClr val="0B1F3A">
+                <a:alpha val="35000"/>
+              </a:srgbClr>
+            </a:outerShdw>
+          </a:effectLst>
+        </p:spPr>
+      </p:sp>
+      <p:sp>
+        <p:nvSpPr>
+          <p:cNvPr id="7" name="Shape 4"/>
+          <p:cNvSpPr/>
+          <p:nvPr/>
+        </p:nvSpPr>
+        <p:spPr>
+          <a:xfrm>
+            <a:off x="11210544" y="1746504"/>
+            <a:ext cx="128016" cy="128016"/>
+          </a:xfrm>
+          <a:prstGeom prst="ellipse">
+            <a:avLst/>
+          </a:prstGeom>
+          <a:solidFill>
+            <a:srgbClr val="FF6B6B"/>
+          </a:solidFill>
+          <a:ln/>
+        </p:spPr>
+      </p:sp>
+      <p:sp>
+        <p:nvSpPr>
+          <p:cNvPr id="8" name="Shape 5"/>
+          <p:cNvSpPr/>
+          <p:nvPr/>
+        </p:nvSpPr>
+        <p:spPr>
+          <a:xfrm>
+            <a:off x="11210544" y="1947672"/>
+            <a:ext cx="128016" cy="128016"/>
+          </a:xfrm>
+          <a:prstGeom prst="ellipse">
+            <a:avLst/>
+          </a:prstGeom>
+          <a:solidFill>
+            <a:srgbClr val="FFD166"/>
+          </a:solidFill>
+          <a:ln/>
+        </p:spPr>
+      </p:sp>
+      <p:sp>
+        <p:nvSpPr>
+          <p:cNvPr id="9" name="Shape 6"/>
+          <p:cNvSpPr/>
+          <p:nvPr/>
+        </p:nvSpPr>
+        <p:spPr>
+          <a:xfrm>
+            <a:off x="11210544" y="2148840"/>
+            <a:ext cx="128016" cy="128016"/>
+          </a:xfrm>
+          <a:prstGeom prst="ellipse">
+            <a:avLst/>
+          </a:prstGeom>
+          <a:solidFill>
+            <a:srgbClr val="2EC4B6"/>
+          </a:solidFill>
+          <a:ln/>
+        </p:spPr>
+      </p:sp>
+      <p:sp>
+        <p:nvSpPr>
+          <p:cNvPr id="10" name="Text 7"/>
+          <p:cNvSpPr/>
+          <p:nvPr/>
+        </p:nvSpPr>
+        <p:spPr>
+          <a:xfrm>
+            <a:off x="914400" y="1728216"/>
+            <a:ext cx="10195560" cy="292608"/>
+          </a:xfrm>
+          <a:prstGeom prst="rect">
+            <a:avLst/>
+          </a:prstGeom>
+          <a:noFill/>
+          <a:ln/>
+        </p:spPr>
+        <p:txBody>
+          <a:bodyPr wrap="square" lIns="0" tIns="0" rIns="0" bIns="0" rtlCol="0" anchor="ctr"/>
+          <a:lstStyle/>
+          <a:p>
+            <a:pPr indent="0" marL="0">
+              <a:buNone/>
+            </a:pPr>
+            <a:r>
+              <a:rPr lang="en-US" sz="1500" b="1" dirty="0">
+                <a:solidFill>
+                  <a:srgbClr val="FF5010"/>
+                </a:solidFill>
+                <a:latin typeface="Calibri" pitchFamily="34" charset="0"/>
+                <a:ea typeface="Calibri" pitchFamily="34" charset="-122"/>
+                <a:cs typeface="Calibri" pitchFamily="34" charset="-120"/>
+              </a:rPr>
+              <a:t>Replace the last two drive-motor lines of simulatePeriodic()</a:t>
+            </a:r>
+            <a:endParaRPr lang="en-US" sz="1500" dirty="0"/>
+          </a:p>
+        </p:txBody>
+      </p:sp>
+      <p:sp>
+        <p:nvSpPr>
+          <p:cNvPr id="11" name="Text 8"/>
+          <p:cNvSpPr/>
+          <p:nvPr/>
+        </p:nvSpPr>
+        <p:spPr>
+          <a:xfrm>
+            <a:off x="914400" y="2057400"/>
+            <a:ext cx="10195560" cy="1170432"/>
+          </a:xfrm>
+          <a:prstGeom prst="rect">
+            <a:avLst/>
+          </a:prstGeom>
+          <a:noFill/>
+          <a:ln/>
+        </p:spPr>
+        <p:txBody>
+          <a:bodyPr wrap="square" lIns="0" tIns="0" rIns="0" bIns="0" rtlCol="0" anchor="t"/>
+          <a:lstStyle/>
+          <a:p>
+            <a:pPr indent="0" marL="0">
+              <a:lnSpc>
+                <a:spcPct val="120000"/>
+              </a:lnSpc>
+              <a:buNone/>
+            </a:pPr>
+            <a:r>
+              <a:rPr lang="en-US" sz="1400" dirty="0">
+                <a:solidFill>
+                  <a:srgbClr val="FFD166"/>
+                </a:solidFill>
+                <a:latin typeface="Courier New" pitchFamily="34" charset="0"/>
+                <a:ea typeface="Courier New" pitchFamily="34" charset="-122"/>
+                <a:cs typeface="Courier New" pitchFamily="34" charset="-120"/>
+              </a:rPr>
+              <a:t>m_driveSim.setRawRotorPosition(</a:t>
+            </a:r>
+            <a:endParaRPr lang="en-US" sz="1400" dirty="0"/>
+          </a:p>
+          <a:p>
+            <a:pPr indent="0" marL="0">
+              <a:lnSpc>
+                <a:spcPct val="120000"/>
+              </a:lnSpc>
+              <a:buNone/>
+            </a:pPr>
+            <a:r>
+              <a:rPr lang="en-US" sz="1400" dirty="0">
+                <a:solidFill>
+                  <a:srgbClr val="9EF01A"/>
+                </a:solidFill>
+                <a:latin typeface="Courier New" pitchFamily="34" charset="0"/>
+                <a:ea typeface="Courier New" pitchFamily="34" charset="-122"/>
+                <a:cs typeface="Courier New" pitchFamily="34" charset="-120"/>
+              </a:rPr>
+              <a:t>    m_driveModel.getAngularPosition() / (2 * Math.PI) * DriveConstants.kDriveGearRatio);</a:t>
+            </a:r>
+            <a:endParaRPr lang="en-US" sz="1400" dirty="0"/>
+          </a:p>
+          <a:p>
+            <a:pPr indent="0" marL="0">
+              <a:lnSpc>
+                <a:spcPct val="120000"/>
+              </a:lnSpc>
+              <a:buNone/>
+            </a:pPr>
+            <a:r>
+              <a:rPr lang="en-US" sz="1400" dirty="0">
+                <a:solidFill>
+                  <a:srgbClr val="FFD166"/>
+                </a:solidFill>
+                <a:latin typeface="Courier New" pitchFamily="34" charset="0"/>
+                <a:ea typeface="Courier New" pitchFamily="34" charset="-122"/>
+                <a:cs typeface="Courier New" pitchFamily="34" charset="-120"/>
+              </a:rPr>
+              <a:t>m_driveSim.setRotorVelocity(</a:t>
+            </a:r>
+            <a:endParaRPr lang="en-US" sz="1400" dirty="0"/>
+          </a:p>
+          <a:p>
+            <a:pPr indent="0" marL="0">
+              <a:lnSpc>
+                <a:spcPct val="120000"/>
+              </a:lnSpc>
+              <a:buNone/>
+            </a:pPr>
+            <a:r>
+              <a:rPr lang="en-US" sz="1400" dirty="0">
+                <a:solidFill>
+                  <a:srgbClr val="9EF01A"/>
+                </a:solidFill>
+                <a:latin typeface="Courier New" pitchFamily="34" charset="0"/>
+                <a:ea typeface="Courier New" pitchFamily="34" charset="-122"/>
+                <a:cs typeface="Courier New" pitchFamily="34" charset="-120"/>
+              </a:rPr>
+              <a:t>    m_driveModel.getAngularVelocity() / (2 * Math.PI) * DriveConstants.kDriveGearRatio);</a:t>
+            </a:r>
+            <a:endParaRPr lang="en-US" sz="1400" dirty="0"/>
+          </a:p>
+        </p:txBody>
+      </p:sp>
+      <p:sp>
+        <p:nvSpPr>
+          <p:cNvPr id="12" name="Shape 9"/>
+          <p:cNvSpPr/>
+          <p:nvPr/>
+        </p:nvSpPr>
+        <p:spPr>
+          <a:xfrm>
+            <a:off x="640080" y="3611880"/>
+            <a:ext cx="10881360" cy="2743200"/>
+          </a:xfrm>
+          <a:prstGeom prst="roundRect">
+            <a:avLst>
+              <a:gd name="adj" fmla="val 3333"/>
+            </a:avLst>
+          </a:prstGeom>
+          <a:solidFill>
+            <a:srgbClr val="F3F6FA"/>
+          </a:solidFill>
+          <a:ln/>
+        </p:spPr>
+      </p:sp>
+      <p:sp>
+        <p:nvSpPr>
+          <p:cNvPr id="13" name="Text 10"/>
+          <p:cNvSpPr/>
+          <p:nvPr/>
+        </p:nvSpPr>
+        <p:spPr>
+          <a:xfrm>
+            <a:off x="914400" y="3886200"/>
+            <a:ext cx="10332720" cy="561975"/>
+          </a:xfrm>
+          <a:prstGeom prst="rect">
+            <a:avLst/>
+          </a:prstGeom>
+          <a:noFill/>
+          <a:ln/>
+        </p:spPr>
+        <p:txBody>
+          <a:bodyPr wrap="square" lIns="0" tIns="0" rIns="0" bIns="0" rtlCol="0" anchor="t"/>
+          <a:lstStyle/>
+          <a:p>
+            <a:pPr indent="0" marL="0">
+              <a:lnSpc>
+                <a:spcPct val="120000"/>
+              </a:lnSpc>
+              <a:buNone/>
+            </a:pPr>
+            <a:r>
+              <a:rPr lang="en-US" sz="2100" b="1" dirty="0">
+                <a:solidFill>
+                  <a:srgbClr val="13294B"/>
+                </a:solidFill>
+                <a:latin typeface="Cambria" pitchFamily="34" charset="0"/>
+                <a:ea typeface="Cambria" pitchFamily="34" charset="-122"/>
+                <a:cs typeface="Cambria" pitchFamily="34" charset="-120"/>
+              </a:rPr>
+              <a:t>The encoder still lives on the rotor — gearbox or not.</a:t>
+            </a:r>
+            <a:endParaRPr lang="en-US" sz="2100" dirty="0"/>
+          </a:p>
+        </p:txBody>
+      </p:sp>
+      <p:sp>
+        <p:nvSpPr>
+          <p:cNvPr id="14" name="Text 11"/>
+          <p:cNvSpPr/>
+          <p:nvPr/>
+        </p:nvSpPr>
+        <p:spPr>
+          <a:xfrm>
+            <a:off x="914400" y="4448175"/>
+            <a:ext cx="10332720" cy="1632585"/>
+          </a:xfrm>
+          <a:prstGeom prst="rect">
+            <a:avLst/>
+          </a:prstGeom>
+          <a:noFill/>
+          <a:ln/>
+        </p:spPr>
+        <p:txBody>
+          <a:bodyPr wrap="square" lIns="0" tIns="0" rIns="0" bIns="0" rtlCol="0" anchor="t"/>
+          <a:lstStyle/>
+          <a:p>
+            <a:pPr indent="0" marL="0">
+              <a:lnSpc>
+                <a:spcPct val="125000"/>
+              </a:lnSpc>
+              <a:buNone/>
+            </a:pPr>
+            <a:r>
+              <a:rPr lang="en-US" sz="1900" dirty="0">
+                <a:solidFill>
+                  <a:srgbClr val="13294B"/>
+                </a:solidFill>
+                <a:latin typeface="Calibri" pitchFamily="34" charset="0"/>
+                <a:ea typeface="Calibri" pitchFamily="34" charset="-122"/>
+                <a:cs typeface="Calibri" pitchFamily="34" charset="-120"/>
+              </a:rPr>
+              <a:t>DCMotorSim now reports wheel-side motion, so this multiplies back by the gear ratio, on top of the radians-to-rotations fix from Lesson 4. The chain stays honest end to end: applied volts spin the rotor, the wheel moves 1/6.75 as fast, getDistanceMeters() divides by that same ratio.</a:t>
+            </a:r>
+            <a:endParaRPr lang="en-US" sz="1900" dirty="0"/>
+          </a:p>
+        </p:txBody>
+      </p:sp>
+      <p:sp>
+        <p:nvSpPr>
+          <p:cNvPr id="15" name="Text 12"/>
+          <p:cNvSpPr/>
+          <p:nvPr/>
+        </p:nvSpPr>
+        <p:spPr>
+          <a:xfrm>
+            <a:off x="640080" y="6446520"/>
+            <a:ext cx="8229600" cy="365760"/>
+          </a:xfrm>
+          <a:prstGeom prst="rect">
+            <a:avLst/>
+          </a:prstGeom>
+          <a:noFill/>
+          <a:ln/>
+        </p:spPr>
+        <p:txBody>
+          <a:bodyPr wrap="square" lIns="0" tIns="0" rIns="0" bIns="0" rtlCol="0" anchor="ctr"/>
+          <a:lstStyle/>
+          <a:p>
+            <a:pPr indent="0" marL="0">
+              <a:buNone/>
+            </a:pPr>
+            <a:r>
+              <a:rPr lang="en-US" sz="2000" spc="100" kern="0" dirty="0">
+                <a:solidFill>
+                  <a:srgbClr val="5B6B84"/>
+                </a:solidFill>
+                <a:latin typeface="Calibri" pitchFamily="34" charset="0"/>
+                <a:ea typeface="Calibri" pitchFamily="34" charset="-122"/>
+                <a:cs typeface="Calibri" pitchFamily="34" charset="-120"/>
+              </a:rPr>
+              <a:t>LEARN JAVA + ROBOT PROGRAMMING · DISTANCE &amp; COMMANDS</a:t>
+            </a:r>
+            <a:endParaRPr lang="en-US" sz="2000" dirty="0"/>
+          </a:p>
+        </p:txBody>
+      </p:sp>
+      <p:sp>
+        <p:nvSpPr>
+          <p:cNvPr id="16" name="Text 13"/>
+          <p:cNvSpPr/>
+          <p:nvPr/>
+        </p:nvSpPr>
+        <p:spPr>
+          <a:xfrm>
+            <a:off x="11002975" y="6446520"/>
+            <a:ext cx="548640" cy="365760"/>
+          </a:xfrm>
+          <a:prstGeom prst="rect">
+            <a:avLst/>
+          </a:prstGeom>
+          <a:noFill/>
+          <a:ln/>
+        </p:spPr>
+        <p:txBody>
+          <a:bodyPr wrap="square" lIns="0" tIns="0" rIns="0" bIns="0" rtlCol="0" anchor="ctr"/>
+          <a:lstStyle/>
+          <a:p>
+            <a:pPr algn="r" indent="0" marL="0">
+              <a:buNone/>
+            </a:pPr>
+            <a:r>
+              <a:rPr lang="en-US" sz="2000" dirty="0">
+                <a:solidFill>
+                  <a:srgbClr val="5B6B84"/>
+                </a:solidFill>
+                <a:latin typeface="Calibri" pitchFamily="34" charset="0"/>
+                <a:ea typeface="Calibri" pitchFamily="34" charset="-122"/>
+                <a:cs typeface="Calibri" pitchFamily="34" charset="-120"/>
+              </a:rPr>
+              <a:t>6</a:t>
+            </a:r>
+            <a:endParaRPr lang="en-US" sz="2000" dirty="0"/>
+          </a:p>
+        </p:txBody>
+      </p:sp>
+      <p:pic>
+        <p:nvPicPr>
+          <p:cNvPr id="17" name="Image 1" descr="/home/user/BasicRobotLessons/docs/presentations/v3/template/assets/logo/team5010-logo-onwhite.png">    </p:cNvPr>
+          <p:cNvPicPr>
+            <a:picLocks noChangeAspect="1"/>
+          </p:cNvPicPr>
+          <p:nvPr/>
+        </p:nvPicPr>
+        <p:blipFill>
+          <a:blip r:embed="rId2"/>
+          <a:stretch>
+            <a:fillRect/>
+          </a:stretch>
+        </p:blipFill>
+        <p:spPr>
+          <a:xfrm>
+            <a:off x="10957255" y="164592"/>
+            <a:ext cx="777240" cy="605859"/>
+          </a:xfrm>
+          <a:prstGeom prst="rect">
+            <a:avLst/>
+          </a:prstGeom>
+        </p:spPr>
+      </p:pic>
+    </p:spTree>
+  </p:cSld>
+  <p:clrMapOvr>
+    <a:masterClrMapping/>
+  </p:clrMapOvr>
+</p:sld>
+</file>
+
+<file path=ppt/slides/slide7.xml><?xml version="1.0" encoding="utf-8"?>
+<p:sld xmlns:a="http://schemas.openxmlformats.org/drawingml/2006/main" xmlns:r="http://schemas.openxmlformats.org/officeDocument/2006/relationships" xmlns:p="http://schemas.openxmlformats.org/presentationml/2006/main">
+  <p:cSld name="Slide 7">
+    <p:bg>
+      <p:bgPr>
+        <a:solidFill>
           <a:srgbClr val="0B1F3A"/>
         </a:solidFill>
       </p:bgPr>
@@ -6946,7 +8438,7 @@
                 <a:ea typeface="Calibri" pitchFamily="34" charset="-122"/>
                 <a:cs typeface="Calibri" pitchFamily="34" charset="-120"/>
               </a:rPr>
-              <a:t>6</a:t>
+              <a:t>7</a:t>
             </a:r>
             <a:endParaRPr lang="en-US" sz="2000" dirty="0"/>
           </a:p>
@@ -6955,632 +8447,6 @@
       <p:pic>
         <p:nvPicPr>
           <p:cNvPr id="14" name="Image 1" descr="/home/user/BasicRobotLessons/docs/presentations/v3/template/assets/logo/team5010-logo-onnavy.png">    </p:cNvPr>
-          <p:cNvPicPr>
-            <a:picLocks noChangeAspect="1"/>
-          </p:cNvPicPr>
-          <p:nvPr/>
-        </p:nvPicPr>
-        <p:blipFill>
-          <a:blip r:embed="rId2"/>
-          <a:stretch>
-            <a:fillRect/>
-          </a:stretch>
-        </p:blipFill>
-        <p:spPr>
-          <a:xfrm>
-            <a:off x="10957255" y="164592"/>
-            <a:ext cx="777240" cy="605859"/>
-          </a:xfrm>
-          <a:prstGeom prst="rect">
-            <a:avLst/>
-          </a:prstGeom>
-        </p:spPr>
-      </p:pic>
-    </p:spTree>
-  </p:cSld>
-  <p:clrMapOvr>
-    <a:masterClrMapping/>
-  </p:clrMapOvr>
-</p:sld>
-</file>
-
-<file path=ppt/slides/slide7.xml><?xml version="1.0" encoding="utf-8"?>
-<p:sld xmlns:a="http://schemas.openxmlformats.org/drawingml/2006/main" xmlns:r="http://schemas.openxmlformats.org/officeDocument/2006/relationships" xmlns:p="http://schemas.openxmlformats.org/presentationml/2006/main">
-  <p:cSld name="Slide 7">
-    <p:bg>
-      <p:bgPr>
-        <a:solidFill>
-          <a:srgbClr val="FFFFFF"/>
-        </a:solidFill>
-      </p:bgPr>
-    </p:bg>
-    <p:spTree>
-      <p:nvGrpSpPr>
-        <p:cNvPr id="1" name=""/>
-        <p:cNvGrpSpPr/>
-        <p:nvPr/>
-      </p:nvGrpSpPr>
-      <p:grpSpPr>
-        <a:xfrm>
-          <a:off x="0" y="0"/>
-          <a:ext cx="0" cy="0"/>
-          <a:chOff x="0" y="0"/>
-          <a:chExt cx="0" cy="0"/>
-        </a:xfrm>
-      </p:grpSpPr>
-      <p:sp>
-        <p:nvSpPr>
-          <p:cNvPr id="2" name="Shape 0"/>
-          <p:cNvSpPr/>
-          <p:nvPr/>
-        </p:nvSpPr>
-        <p:spPr>
-          <a:xfrm>
-            <a:off x="640080" y="457200"/>
-            <a:ext cx="566928" cy="566928"/>
-          </a:xfrm>
-          <a:prstGeom prst="ellipse">
-            <a:avLst/>
-          </a:prstGeom>
-          <a:solidFill>
-            <a:srgbClr val="0B1F3A"/>
-          </a:solidFill>
-          <a:ln/>
-        </p:spPr>
-      </p:sp>
-      <p:pic>
-        <p:nvPicPr>
-          <p:cNvPr id="3" name="Image 0" descr="/home/user/BasicRobotLessons/docs/presentations/v3/template/assets/icons/filecode_teal.png">    </p:cNvPr>
-          <p:cNvPicPr>
-            <a:picLocks noChangeAspect="1"/>
-          </p:cNvPicPr>
-          <p:nvPr/>
-        </p:nvPicPr>
-        <p:blipFill>
-          <a:blip r:embed="rId1"/>
-          <a:stretch>
-            <a:fillRect/>
-          </a:stretch>
-        </p:blipFill>
-        <p:spPr>
-          <a:xfrm>
-            <a:off x="768096" y="585216"/>
-            <a:ext cx="310896" cy="310896"/>
-          </a:xfrm>
-          <a:prstGeom prst="rect">
-            <a:avLst/>
-          </a:prstGeom>
-        </p:spPr>
-      </p:pic>
-      <p:sp>
-        <p:nvSpPr>
-          <p:cNvPr id="4" name="Text 1"/>
-          <p:cNvSpPr/>
-          <p:nvPr/>
-        </p:nvSpPr>
-        <p:spPr>
-          <a:xfrm>
-            <a:off x="1389888" y="402336"/>
-            <a:ext cx="9144000" cy="365760"/>
-          </a:xfrm>
-          <a:prstGeom prst="rect">
-            <a:avLst/>
-          </a:prstGeom>
-          <a:noFill/>
-          <a:ln/>
-        </p:spPr>
-        <p:txBody>
-          <a:bodyPr wrap="square" lIns="0" tIns="0" rIns="0" bIns="0" rtlCol="0" anchor="ctr"/>
-          <a:lstStyle/>
-          <a:p>
-            <a:pPr indent="0" marL="0">
-              <a:buNone/>
-            </a:pPr>
-            <a:r>
-              <a:rPr lang="en-US" sz="2000" b="1" spc="150" kern="0" dirty="0">
-                <a:solidFill>
-                  <a:srgbClr val="FF5010"/>
-                </a:solidFill>
-                <a:latin typeface="Calibri" pitchFamily="34" charset="0"/>
-                <a:ea typeface="Calibri" pitchFamily="34" charset="-122"/>
-                <a:cs typeface="Calibri" pitchFamily="34" charset="-120"/>
-              </a:rPr>
-              <a:t>SECTION 3 · DRIVEMODULE.JAVA</a:t>
-            </a:r>
-            <a:endParaRPr lang="en-US" sz="2000" dirty="0"/>
-          </a:p>
-        </p:txBody>
-      </p:sp>
-      <p:sp>
-        <p:nvSpPr>
-          <p:cNvPr id="5" name="Text 2"/>
-          <p:cNvSpPr/>
-          <p:nvPr/>
-        </p:nvSpPr>
-        <p:spPr>
-          <a:xfrm>
-            <a:off x="1371600" y="749808"/>
-            <a:ext cx="9418320" cy="594360"/>
-          </a:xfrm>
-          <a:prstGeom prst="rect">
-            <a:avLst/>
-          </a:prstGeom>
-          <a:noFill/>
-          <a:ln/>
-        </p:spPr>
-        <p:txBody>
-          <a:bodyPr wrap="square" lIns="0" tIns="0" rIns="0" bIns="0" rtlCol="0" anchor="ctr"/>
-          <a:lstStyle/>
-          <a:p>
-            <a:pPr indent="0" marL="0">
-              <a:buNone/>
-            </a:pPr>
-            <a:r>
-              <a:rPr lang="en-US" sz="3000" b="1" dirty="0">
-                <a:solidFill>
-                  <a:srgbClr val="13294B"/>
-                </a:solidFill>
-                <a:latin typeface="Cambria" pitchFamily="34" charset="0"/>
-                <a:ea typeface="Cambria" pitchFamily="34" charset="-122"/>
-                <a:cs typeface="Cambria" pitchFamily="34" charset="-120"/>
-              </a:rPr>
-              <a:t>Set up, work, wait for done, clean up</a:t>
-            </a:r>
-            <a:endParaRPr lang="en-US" sz="3000" dirty="0"/>
-          </a:p>
-        </p:txBody>
-      </p:sp>
-      <p:sp>
-        <p:nvSpPr>
-          <p:cNvPr id="6" name="Shape 3"/>
-          <p:cNvSpPr/>
-          <p:nvPr/>
-        </p:nvSpPr>
-        <p:spPr>
-          <a:xfrm>
-            <a:off x="640080" y="1371600"/>
-            <a:ext cx="10881360" cy="3794760"/>
-          </a:xfrm>
-          <a:prstGeom prst="roundRect">
-            <a:avLst>
-              <a:gd name="adj" fmla="val 2892"/>
-            </a:avLst>
-          </a:prstGeom>
-          <a:solidFill>
-            <a:srgbClr val="0B1F3A"/>
-          </a:solidFill>
-          <a:ln/>
-          <a:effectLst>
-            <a:outerShdw sx="100000" sy="100000" kx="0" ky="0" algn="bl" rotWithShape="0" blurRad="101600" dist="38100" dir="5400000">
-              <a:srgbClr val="0B1F3A">
-                <a:alpha val="35000"/>
-              </a:srgbClr>
-            </a:outerShdw>
-          </a:effectLst>
-        </p:spPr>
-      </p:sp>
-      <p:sp>
-        <p:nvSpPr>
-          <p:cNvPr id="7" name="Shape 4"/>
-          <p:cNvSpPr/>
-          <p:nvPr/>
-        </p:nvSpPr>
-        <p:spPr>
-          <a:xfrm>
-            <a:off x="11210544" y="1517904"/>
-            <a:ext cx="128016" cy="128016"/>
-          </a:xfrm>
-          <a:prstGeom prst="ellipse">
-            <a:avLst/>
-          </a:prstGeom>
-          <a:solidFill>
-            <a:srgbClr val="FF6B6B"/>
-          </a:solidFill>
-          <a:ln/>
-        </p:spPr>
-      </p:sp>
-      <p:sp>
-        <p:nvSpPr>
-          <p:cNvPr id="8" name="Shape 5"/>
-          <p:cNvSpPr/>
-          <p:nvPr/>
-        </p:nvSpPr>
-        <p:spPr>
-          <a:xfrm>
-            <a:off x="11210544" y="1719072"/>
-            <a:ext cx="128016" cy="128016"/>
-          </a:xfrm>
-          <a:prstGeom prst="ellipse">
-            <a:avLst/>
-          </a:prstGeom>
-          <a:solidFill>
-            <a:srgbClr val="FFD166"/>
-          </a:solidFill>
-          <a:ln/>
-        </p:spPr>
-      </p:sp>
-      <p:sp>
-        <p:nvSpPr>
-          <p:cNvPr id="9" name="Shape 6"/>
-          <p:cNvSpPr/>
-          <p:nvPr/>
-        </p:nvSpPr>
-        <p:spPr>
-          <a:xfrm>
-            <a:off x="11210544" y="1920240"/>
-            <a:ext cx="128016" cy="128016"/>
-          </a:xfrm>
-          <a:prstGeom prst="ellipse">
-            <a:avLst/>
-          </a:prstGeom>
-          <a:solidFill>
-            <a:srgbClr val="2EC4B6"/>
-          </a:solidFill>
-          <a:ln/>
-        </p:spPr>
-      </p:sp>
-      <p:sp>
-        <p:nvSpPr>
-          <p:cNvPr id="10" name="Text 7"/>
-          <p:cNvSpPr/>
-          <p:nvPr/>
-        </p:nvSpPr>
-        <p:spPr>
-          <a:xfrm>
-            <a:off x="914400" y="1499616"/>
-            <a:ext cx="10195560" cy="292608"/>
-          </a:xfrm>
-          <a:prstGeom prst="rect">
-            <a:avLst/>
-          </a:prstGeom>
-          <a:noFill/>
-          <a:ln/>
-        </p:spPr>
-        <p:txBody>
-          <a:bodyPr wrap="square" lIns="0" tIns="0" rIns="0" bIns="0" rtlCol="0" anchor="ctr"/>
-          <a:lstStyle/>
-          <a:p>
-            <a:pPr indent="0" marL="0">
-              <a:buNone/>
-            </a:pPr>
-            <a:r>
-              <a:rPr lang="en-US" sz="1500" b="1" dirty="0">
-                <a:solidFill>
-                  <a:srgbClr val="FF5010"/>
-                </a:solidFill>
-                <a:latin typeface="Calibri" pitchFamily="34" charset="0"/>
-                <a:ea typeface="Calibri" pitchFamily="34" charset="-122"/>
-                <a:cs typeface="Calibri" pitchFamily="34" charset="-120"/>
-              </a:rPr>
-              <a:t>Add to DriveModule, with the other command factories</a:t>
-            </a:r>
-            <a:endParaRPr lang="en-US" sz="1500" dirty="0"/>
-          </a:p>
-        </p:txBody>
-      </p:sp>
-      <p:sp>
-        <p:nvSpPr>
-          <p:cNvPr id="11" name="Text 8"/>
-          <p:cNvSpPr/>
-          <p:nvPr/>
-        </p:nvSpPr>
-        <p:spPr>
-          <a:xfrm>
-            <a:off x="914400" y="1828800"/>
-            <a:ext cx="10195560" cy="3136392"/>
-          </a:xfrm>
-          <a:prstGeom prst="rect">
-            <a:avLst/>
-          </a:prstGeom>
-          <a:noFill/>
-          <a:ln/>
-        </p:spPr>
-        <p:txBody>
-          <a:bodyPr wrap="square" lIns="0" tIns="0" rIns="0" bIns="0" rtlCol="0" anchor="t"/>
-          <a:lstStyle/>
-          <a:p>
-            <a:pPr indent="0" marL="0">
-              <a:lnSpc>
-                <a:spcPct val="120000"/>
-              </a:lnSpc>
-              <a:buNone/>
-            </a:pPr>
-            <a:r>
-              <a:rPr lang="en-US" sz="1300" dirty="0">
-                <a:solidFill>
-                  <a:srgbClr val="7FA8C9"/>
-                </a:solidFill>
-                <a:latin typeface="Courier New" pitchFamily="34" charset="0"/>
-                <a:ea typeface="Courier New" pitchFamily="34" charset="-122"/>
-                <a:cs typeface="Courier New" pitchFamily="34" charset="-120"/>
-              </a:rPr>
-              <a:t>/** Drives forward 'meters' at 'speed', then stops. Finishes on its own. */</a:t>
-            </a:r>
-            <a:endParaRPr lang="en-US" sz="1300" dirty="0"/>
-          </a:p>
-          <a:p>
-            <a:pPr indent="0" marL="0">
-              <a:lnSpc>
-                <a:spcPct val="120000"/>
-              </a:lnSpc>
-              <a:buNone/>
-            </a:pPr>
-            <a:r>
-              <a:rPr lang="en-US" sz="1300" dirty="0">
-                <a:solidFill>
-                  <a:srgbClr val="FFD166"/>
-                </a:solidFill>
-                <a:latin typeface="Courier New" pitchFamily="34" charset="0"/>
-                <a:ea typeface="Courier New" pitchFamily="34" charset="-122"/>
-                <a:cs typeface="Courier New" pitchFamily="34" charset="-120"/>
-              </a:rPr>
-              <a:t>public Command driveDistance(double meters, double speed) {</a:t>
-            </a:r>
-            <a:endParaRPr lang="en-US" sz="1300" dirty="0"/>
-          </a:p>
-          <a:p>
-            <a:pPr indent="0" marL="0">
-              <a:lnSpc>
-                <a:spcPct val="120000"/>
-              </a:lnSpc>
-              <a:buNone/>
-            </a:pPr>
-            <a:r>
-              <a:rPr lang="en-US" sz="1300" dirty="0">
-                <a:solidFill>
-                  <a:srgbClr val="D7E3F4"/>
-                </a:solidFill>
-                <a:latin typeface="Courier New" pitchFamily="34" charset="0"/>
-                <a:ea typeface="Courier New" pitchFamily="34" charset="-122"/>
-                <a:cs typeface="Courier New" pitchFamily="34" charset="-120"/>
-              </a:rPr>
-              <a:t>  return run(coroutine -&gt; {</a:t>
-            </a:r>
-            <a:endParaRPr lang="en-US" sz="1300" dirty="0"/>
-          </a:p>
-          <a:p>
-            <a:pPr indent="0" marL="0">
-              <a:lnSpc>
-                <a:spcPct val="120000"/>
-              </a:lnSpc>
-              <a:buNone/>
-            </a:pPr>
-            <a:r>
-              <a:rPr lang="en-US" sz="1300" dirty="0">
-                <a:solidFill>
-                  <a:srgbClr val="D7E3F4"/>
-                </a:solidFill>
-                <a:latin typeface="Courier New" pitchFamily="34" charset="0"/>
-                <a:ea typeface="Courier New" pitchFamily="34" charset="-122"/>
-                <a:cs typeface="Courier New" pitchFamily="34" charset="-120"/>
-              </a:rPr>
-              <a:t>        m_driveMotor.setPosition(0);                              // 1. zero it</a:t>
-            </a:r>
-            <a:endParaRPr lang="en-US" sz="1300" dirty="0"/>
-          </a:p>
-          <a:p>
-            <a:pPr indent="0" marL="0">
-              <a:lnSpc>
-                <a:spcPct val="120000"/>
-              </a:lnSpc>
-              <a:buNone/>
-            </a:pPr>
-            <a:r>
-              <a:rPr lang="en-US" sz="1300" dirty="0">
-                <a:solidFill>
-                  <a:srgbClr val="D7E3F4"/>
-                </a:solidFill>
-                <a:latin typeface="Courier New" pitchFamily="34" charset="0"/>
-                <a:ea typeface="Courier New" pitchFamily="34" charset="-122"/>
-                <a:cs typeface="Courier New" pitchFamily="34" charset="-120"/>
-              </a:rPr>
-              <a:t>        m_driveMotor.setThrottle(speed);                          // 2. drive...</a:t>
-            </a:r>
-            <a:endParaRPr lang="en-US" sz="1300" dirty="0"/>
-          </a:p>
-          <a:p>
-            <a:pPr indent="0" marL="0">
-              <a:lnSpc>
-                <a:spcPct val="120000"/>
-              </a:lnSpc>
-              <a:buNone/>
-            </a:pPr>
-            <a:r>
-              <a:rPr lang="en-US" sz="1300" dirty="0">
-                <a:solidFill>
-                  <a:srgbClr val="9EF01A"/>
-                </a:solidFill>
-                <a:latin typeface="Courier New" pitchFamily="34" charset="0"/>
-                <a:ea typeface="Courier New" pitchFamily="34" charset="-122"/>
-                <a:cs typeface="Courier New" pitchFamily="34" charset="-120"/>
-              </a:rPr>
-              <a:t>        coroutine.waitUntil(() -&gt; getDistanceMeters() &gt;= meters); // 3. ...wait</a:t>
-            </a:r>
-            <a:endParaRPr lang="en-US" sz="1300" dirty="0"/>
-          </a:p>
-          <a:p>
-            <a:pPr indent="0" marL="0">
-              <a:lnSpc>
-                <a:spcPct val="120000"/>
-              </a:lnSpc>
-              <a:buNone/>
-            </a:pPr>
-            <a:r>
-              <a:rPr lang="en-US" sz="1300" dirty="0">
-                <a:solidFill>
-                  <a:srgbClr val="D7E3F4"/>
-                </a:solidFill>
-                <a:latin typeface="Courier New" pitchFamily="34" charset="0"/>
-                <a:ea typeface="Courier New" pitchFamily="34" charset="-122"/>
-                <a:cs typeface="Courier New" pitchFamily="34" charset="-120"/>
-              </a:rPr>
-              <a:t>        m_driveMotor.setThrottle(0);                              // 4. stop</a:t>
-            </a:r>
-            <a:endParaRPr lang="en-US" sz="1300" dirty="0"/>
-          </a:p>
-          <a:p>
-            <a:pPr indent="0" marL="0">
-              <a:lnSpc>
-                <a:spcPct val="120000"/>
-              </a:lnSpc>
-              <a:buNone/>
-            </a:pPr>
-            <a:r>
-              <a:rPr lang="en-US" sz="1300" dirty="0">
-                <a:solidFill>
-                  <a:srgbClr val="D7E3F4"/>
-                </a:solidFill>
-                <a:latin typeface="Courier New" pitchFamily="34" charset="0"/>
-                <a:ea typeface="Courier New" pitchFamily="34" charset="-122"/>
-                <a:cs typeface="Courier New" pitchFamily="34" charset="-120"/>
-              </a:rPr>
-              <a:t>      })</a:t>
-            </a:r>
-            <a:endParaRPr lang="en-US" sz="1300" dirty="0"/>
-          </a:p>
-          <a:p>
-            <a:pPr indent="0" marL="0">
-              <a:lnSpc>
-                <a:spcPct val="120000"/>
-              </a:lnSpc>
-              <a:buNone/>
-            </a:pPr>
-            <a:r>
-              <a:rPr lang="en-US" sz="1300" dirty="0">
-                <a:solidFill>
-                  <a:srgbClr val="9EF01A"/>
-                </a:solidFill>
-                <a:latin typeface="Courier New" pitchFamily="34" charset="0"/>
-                <a:ea typeface="Courier New" pitchFamily="34" charset="-122"/>
-                <a:cs typeface="Courier New" pitchFamily="34" charset="-120"/>
-              </a:rPr>
-              <a:t>      .whenCanceled(() -&gt; m_driveMotor.setThrottle(0))</a:t>
-            </a:r>
-            <a:endParaRPr lang="en-US" sz="1300" dirty="0"/>
-          </a:p>
-          <a:p>
-            <a:pPr indent="0" marL="0">
-              <a:lnSpc>
-                <a:spcPct val="120000"/>
-              </a:lnSpc>
-              <a:buNone/>
-            </a:pPr>
-            <a:r>
-              <a:rPr lang="en-US" sz="1300" dirty="0">
-                <a:solidFill>
-                  <a:srgbClr val="9EF01A"/>
-                </a:solidFill>
-                <a:latin typeface="Courier New" pitchFamily="34" charset="0"/>
-                <a:ea typeface="Courier New" pitchFamily="34" charset="-122"/>
-                <a:cs typeface="Courier New" pitchFamily="34" charset="-120"/>
-              </a:rPr>
-              <a:t>      .named("Drive Distance");</a:t>
-            </a:r>
-            <a:endParaRPr lang="en-US" sz="1300" dirty="0"/>
-          </a:p>
-          <a:p>
-            <a:pPr indent="0" marL="0">
-              <a:lnSpc>
-                <a:spcPct val="120000"/>
-              </a:lnSpc>
-              <a:buNone/>
-            </a:pPr>
-            <a:r>
-              <a:rPr lang="en-US" sz="1300" dirty="0">
-                <a:solidFill>
-                  <a:srgbClr val="D7E3F4"/>
-                </a:solidFill>
-                <a:latin typeface="Courier New" pitchFamily="34" charset="0"/>
-                <a:ea typeface="Courier New" pitchFamily="34" charset="-122"/>
-                <a:cs typeface="Courier New" pitchFamily="34" charset="-120"/>
-              </a:rPr>
-              <a:t>}</a:t>
-            </a:r>
-            <a:endParaRPr lang="en-US" sz="1300" dirty="0"/>
-          </a:p>
-        </p:txBody>
-      </p:sp>
-      <p:sp>
-        <p:nvSpPr>
-          <p:cNvPr id="12" name="Text 9"/>
-          <p:cNvSpPr/>
-          <p:nvPr/>
-        </p:nvSpPr>
-        <p:spPr>
-          <a:xfrm>
-            <a:off x="640080" y="6446520"/>
-            <a:ext cx="8229600" cy="365760"/>
-          </a:xfrm>
-          <a:prstGeom prst="rect">
-            <a:avLst/>
-          </a:prstGeom>
-          <a:noFill/>
-          <a:ln/>
-        </p:spPr>
-        <p:txBody>
-          <a:bodyPr wrap="square" lIns="0" tIns="0" rIns="0" bIns="0" rtlCol="0" anchor="ctr"/>
-          <a:lstStyle/>
-          <a:p>
-            <a:pPr indent="0" marL="0">
-              <a:buNone/>
-            </a:pPr>
-            <a:r>
-              <a:rPr lang="en-US" sz="2000" spc="100" kern="0" dirty="0">
-                <a:solidFill>
-                  <a:srgbClr val="5B6B84"/>
-                </a:solidFill>
-                <a:latin typeface="Calibri" pitchFamily="34" charset="0"/>
-                <a:ea typeface="Calibri" pitchFamily="34" charset="-122"/>
-                <a:cs typeface="Calibri" pitchFamily="34" charset="-120"/>
-              </a:rPr>
-              <a:t>LEARN JAVA + ROBOT PROGRAMMING · DISTANCE &amp; COMMANDS</a:t>
-            </a:r>
-            <a:endParaRPr lang="en-US" sz="2000" dirty="0"/>
-          </a:p>
-        </p:txBody>
-      </p:sp>
-      <p:sp>
-        <p:nvSpPr>
-          <p:cNvPr id="13" name="Text 10"/>
-          <p:cNvSpPr/>
-          <p:nvPr/>
-        </p:nvSpPr>
-        <p:spPr>
-          <a:xfrm>
-            <a:off x="11002975" y="6446520"/>
-            <a:ext cx="548640" cy="365760"/>
-          </a:xfrm>
-          <a:prstGeom prst="rect">
-            <a:avLst/>
-          </a:prstGeom>
-          <a:noFill/>
-          <a:ln/>
-        </p:spPr>
-        <p:txBody>
-          <a:bodyPr wrap="square" lIns="0" tIns="0" rIns="0" bIns="0" rtlCol="0" anchor="ctr"/>
-          <a:lstStyle/>
-          <a:p>
-            <a:pPr algn="r" indent="0" marL="0">
-              <a:buNone/>
-            </a:pPr>
-            <a:r>
-              <a:rPr lang="en-US" sz="2000" dirty="0">
-                <a:solidFill>
-                  <a:srgbClr val="5B6B84"/>
-                </a:solidFill>
-                <a:latin typeface="Calibri" pitchFamily="34" charset="0"/>
-                <a:ea typeface="Calibri" pitchFamily="34" charset="-122"/>
-                <a:cs typeface="Calibri" pitchFamily="34" charset="-120"/>
-              </a:rPr>
-              <a:t>7</a:t>
-            </a:r>
-            <a:endParaRPr lang="en-US" sz="2000" dirty="0"/>
-          </a:p>
-        </p:txBody>
-      </p:sp>
-      <p:pic>
-        <p:nvPicPr>
-          <p:cNvPr id="14" name="Image 1" descr="/home/user/BasicRobotLessons/docs/presentations/v3/template/assets/logo/team5010-logo-onwhite.png">    </p:cNvPr>
           <p:cNvPicPr>
             <a:picLocks noChangeAspect="1"/>
           </p:cNvPicPr>
@@ -7656,7 +8522,7 @@
       </p:sp>
       <p:pic>
         <p:nvPicPr>
-          <p:cNvPr id="3" name="Image 0" descr="/home/user/BasicRobotLessons/docs/presentations/v3/template/assets/icons/lightbulb_white.png">    </p:cNvPr>
+          <p:cNvPr id="3" name="Image 0" descr="/home/user/BasicRobotLessons/docs/presentations/v3/template/assets/icons/filecode_teal.png">    </p:cNvPr>
           <p:cNvPicPr>
             <a:picLocks noChangeAspect="1"/>
           </p:cNvPicPr>
@@ -7711,7 +8577,7 @@
                 <a:ea typeface="Calibri" pitchFamily="34" charset="-122"/>
                 <a:cs typeface="Calibri" pitchFamily="34" charset="-120"/>
               </a:rPr>
-              <a:t>SECTION 3 · WHAT WAITUNTIL DOES</a:t>
+              <a:t>SECTION 3 · DRIVEMODULE.JAVA</a:t>
             </a:r>
             <a:endParaRPr lang="en-US" sz="2000" dirty="0"/>
           </a:p>
@@ -7750,7 +8616,7 @@
                 <a:ea typeface="Cambria" pitchFamily="34" charset="-122"/>
                 <a:cs typeface="Cambria" pitchFamily="34" charset="-120"/>
               </a:rPr>
-              <a:t>Suspend here, checking every tick, until true</a:t>
+              <a:t>Set up, work, wait for done, clean up</a:t>
             </a:r>
             <a:endParaRPr lang="en-US" sz="3000" dirty="0"/>
           </a:p>
@@ -7764,30 +8630,97 @@
         </p:nvSpPr>
         <p:spPr>
           <a:xfrm>
-            <a:off x="640080" y="1600200"/>
-            <a:ext cx="5349240" cy="4251960"/>
+            <a:off x="640080" y="1371600"/>
+            <a:ext cx="10881360" cy="3794760"/>
           </a:xfrm>
           <a:prstGeom prst="roundRect">
             <a:avLst>
-              <a:gd name="adj" fmla="val 2151"/>
+              <a:gd name="adj" fmla="val 2892"/>
             </a:avLst>
           </a:prstGeom>
           <a:solidFill>
-            <a:srgbClr val="F3F6FA"/>
+            <a:srgbClr val="0B1F3A"/>
           </a:solidFill>
           <a:ln/>
-        </p:spPr>
-      </p:sp>
-      <p:sp>
-        <p:nvSpPr>
-          <p:cNvPr id="7" name="Text 4"/>
-          <p:cNvSpPr/>
-          <p:nvPr/>
-        </p:nvSpPr>
-        <p:spPr>
-          <a:xfrm>
-            <a:off x="914400" y="1874520"/>
-            <a:ext cx="4800600" cy="365760"/>
+          <a:effectLst>
+            <a:outerShdw sx="100000" sy="100000" kx="0" ky="0" algn="bl" rotWithShape="0" blurRad="101600" dist="38100" dir="5400000">
+              <a:srgbClr val="0B1F3A">
+                <a:alpha val="35000"/>
+              </a:srgbClr>
+            </a:outerShdw>
+          </a:effectLst>
+        </p:spPr>
+      </p:sp>
+      <p:sp>
+        <p:nvSpPr>
+          <p:cNvPr id="7" name="Shape 4"/>
+          <p:cNvSpPr/>
+          <p:nvPr/>
+        </p:nvSpPr>
+        <p:spPr>
+          <a:xfrm>
+            <a:off x="11210544" y="1517904"/>
+            <a:ext cx="128016" cy="128016"/>
+          </a:xfrm>
+          <a:prstGeom prst="ellipse">
+            <a:avLst/>
+          </a:prstGeom>
+          <a:solidFill>
+            <a:srgbClr val="FF6B6B"/>
+          </a:solidFill>
+          <a:ln/>
+        </p:spPr>
+      </p:sp>
+      <p:sp>
+        <p:nvSpPr>
+          <p:cNvPr id="8" name="Shape 5"/>
+          <p:cNvSpPr/>
+          <p:nvPr/>
+        </p:nvSpPr>
+        <p:spPr>
+          <a:xfrm>
+            <a:off x="11210544" y="1719072"/>
+            <a:ext cx="128016" cy="128016"/>
+          </a:xfrm>
+          <a:prstGeom prst="ellipse">
+            <a:avLst/>
+          </a:prstGeom>
+          <a:solidFill>
+            <a:srgbClr val="FFD166"/>
+          </a:solidFill>
+          <a:ln/>
+        </p:spPr>
+      </p:sp>
+      <p:sp>
+        <p:nvSpPr>
+          <p:cNvPr id="9" name="Shape 6"/>
+          <p:cNvSpPr/>
+          <p:nvPr/>
+        </p:nvSpPr>
+        <p:spPr>
+          <a:xfrm>
+            <a:off x="11210544" y="1920240"/>
+            <a:ext cx="128016" cy="128016"/>
+          </a:xfrm>
+          <a:prstGeom prst="ellipse">
+            <a:avLst/>
+          </a:prstGeom>
+          <a:solidFill>
+            <a:srgbClr val="2EC4B6"/>
+          </a:solidFill>
+          <a:ln/>
+        </p:spPr>
+      </p:sp>
+      <p:sp>
+        <p:nvSpPr>
+          <p:cNvPr id="10" name="Text 7"/>
+          <p:cNvSpPr/>
+          <p:nvPr/>
+        </p:nvSpPr>
+        <p:spPr>
+          <a:xfrm>
+            <a:off x="914400" y="1499616"/>
+            <a:ext cx="10195560" cy="292608"/>
           </a:xfrm>
           <a:prstGeom prst="rect">
             <a:avLst/>
@@ -7803,7 +8736,7 @@
               <a:buNone/>
             </a:pPr>
             <a:r>
-              <a:rPr lang="en-US" sz="2000" b="1" spc="50" kern="0" dirty="0">
+              <a:rPr lang="en-US" sz="1500" b="1" dirty="0">
                 <a:solidFill>
                   <a:srgbClr val="FF5010"/>
                 </a:solidFill>
@@ -7811,22 +8744,22 @@
                 <a:ea typeface="Calibri" pitchFamily="34" charset="-122"/>
                 <a:cs typeface="Calibri" pitchFamily="34" charset="-120"/>
               </a:rPr>
-              <a:t>COROUTINE.WAITUNTIL(CONDITION)</a:t>
-            </a:r>
-            <a:endParaRPr lang="en-US" sz="2000" dirty="0"/>
-          </a:p>
-        </p:txBody>
-      </p:sp>
-      <p:sp>
-        <p:nvSpPr>
-          <p:cNvPr id="8" name="Text 5"/>
-          <p:cNvSpPr/>
-          <p:nvPr/>
-        </p:nvSpPr>
-        <p:spPr>
-          <a:xfrm>
-            <a:off x="914400" y="2331720"/>
-            <a:ext cx="4800600" cy="561975"/>
+              <a:t>Add to DriveModule, with the other command factories</a:t>
+            </a:r>
+            <a:endParaRPr lang="en-US" sz="1500" dirty="0"/>
+          </a:p>
+        </p:txBody>
+      </p:sp>
+      <p:sp>
+        <p:nvSpPr>
+          <p:cNvPr id="11" name="Text 8"/>
+          <p:cNvSpPr/>
+          <p:nvPr/>
+        </p:nvSpPr>
+        <p:spPr>
+          <a:xfrm>
+            <a:off x="914400" y="1828800"/>
+            <a:ext cx="10195560" cy="3136392"/>
           </a:xfrm>
           <a:prstGeom prst="rect">
             <a:avLst/>
@@ -7845,57 +8778,254 @@
               <a:buNone/>
             </a:pPr>
             <a:r>
-              <a:rPr lang="en-US" sz="2100" b="1" dirty="0">
-                <a:solidFill>
-                  <a:srgbClr val="13294B"/>
-                </a:solidFill>
-                <a:latin typeface="Cambria" pitchFamily="34" charset="0"/>
-                <a:ea typeface="Cambria" pitchFamily="34" charset="-122"/>
-                <a:cs typeface="Cambria" pitchFamily="34" charset="-120"/>
-              </a:rPr>
-              <a:t>Suspends the command right here.</a:t>
-            </a:r>
-            <a:endParaRPr lang="en-US" sz="2100" dirty="0"/>
-          </a:p>
-        </p:txBody>
-      </p:sp>
-      <p:sp>
-        <p:nvSpPr>
-          <p:cNvPr id="9" name="Text 6"/>
-          <p:cNvSpPr/>
-          <p:nvPr/>
-        </p:nvSpPr>
-        <p:spPr>
-          <a:xfrm>
-            <a:off x="914400" y="2893695"/>
-            <a:ext cx="4800600" cy="2684145"/>
-          </a:xfrm>
-          <a:prstGeom prst="rect">
-            <a:avLst/>
-          </a:prstGeom>
-          <a:noFill/>
-          <a:ln/>
-        </p:spPr>
-        <p:txBody>
-          <a:bodyPr wrap="square" lIns="0" tIns="0" rIns="0" bIns="0" rtlCol="0" anchor="t"/>
-          <a:lstStyle/>
+              <a:rPr lang="en-US" sz="1300" dirty="0">
+                <a:solidFill>
+                  <a:srgbClr val="7FA8C9"/>
+                </a:solidFill>
+                <a:latin typeface="Courier New" pitchFamily="34" charset="0"/>
+                <a:ea typeface="Courier New" pitchFamily="34" charset="-122"/>
+                <a:cs typeface="Courier New" pitchFamily="34" charset="-120"/>
+              </a:rPr>
+              <a:t>/** Drives forward 'meters' at 'speed', then stops. Finishes on its own. */</a:t>
+            </a:r>
+            <a:endParaRPr lang="en-US" sz="1300" dirty="0"/>
+          </a:p>
           <a:p>
             <a:pPr indent="0" marL="0">
               <a:lnSpc>
-                <a:spcPct val="125000"/>
+                <a:spcPct val="120000"/>
               </a:lnSpc>
               <a:buNone/>
             </a:pPr>
             <a:r>
-              <a:rPr lang="en-US" sz="2000" dirty="0">
-                <a:solidFill>
-                  <a:srgbClr val="13294B"/>
+              <a:rPr lang="en-US" sz="1300" dirty="0">
+                <a:solidFill>
+                  <a:srgbClr val="FFD166"/>
+                </a:solidFill>
+                <a:latin typeface="Courier New" pitchFamily="34" charset="0"/>
+                <a:ea typeface="Courier New" pitchFamily="34" charset="-122"/>
+                <a:cs typeface="Courier New" pitchFamily="34" charset="-120"/>
+              </a:rPr>
+              <a:t>public Command driveDistance(double meters, double speed) {</a:t>
+            </a:r>
+            <a:endParaRPr lang="en-US" sz="1300" dirty="0"/>
+          </a:p>
+          <a:p>
+            <a:pPr indent="0" marL="0">
+              <a:lnSpc>
+                <a:spcPct val="120000"/>
+              </a:lnSpc>
+              <a:buNone/>
+            </a:pPr>
+            <a:r>
+              <a:rPr lang="en-US" sz="1300" dirty="0">
+                <a:solidFill>
+                  <a:srgbClr val="D7E3F4"/>
+                </a:solidFill>
+                <a:latin typeface="Courier New" pitchFamily="34" charset="0"/>
+                <a:ea typeface="Courier New" pitchFamily="34" charset="-122"/>
+                <a:cs typeface="Courier New" pitchFamily="34" charset="-120"/>
+              </a:rPr>
+              <a:t>  return run(coroutine -&gt; {</a:t>
+            </a:r>
+            <a:endParaRPr lang="en-US" sz="1300" dirty="0"/>
+          </a:p>
+          <a:p>
+            <a:pPr indent="0" marL="0">
+              <a:lnSpc>
+                <a:spcPct val="120000"/>
+              </a:lnSpc>
+              <a:buNone/>
+            </a:pPr>
+            <a:r>
+              <a:rPr lang="en-US" sz="1300" dirty="0">
+                <a:solidFill>
+                  <a:srgbClr val="D7E3F4"/>
+                </a:solidFill>
+                <a:latin typeface="Courier New" pitchFamily="34" charset="0"/>
+                <a:ea typeface="Courier New" pitchFamily="34" charset="-122"/>
+                <a:cs typeface="Courier New" pitchFamily="34" charset="-120"/>
+              </a:rPr>
+              <a:t>        m_driveMotor.setPosition(0);                              // 1. zero it</a:t>
+            </a:r>
+            <a:endParaRPr lang="en-US" sz="1300" dirty="0"/>
+          </a:p>
+          <a:p>
+            <a:pPr indent="0" marL="0">
+              <a:lnSpc>
+                <a:spcPct val="120000"/>
+              </a:lnSpc>
+              <a:buNone/>
+            </a:pPr>
+            <a:r>
+              <a:rPr lang="en-US" sz="1300" dirty="0">
+                <a:solidFill>
+                  <a:srgbClr val="D7E3F4"/>
+                </a:solidFill>
+                <a:latin typeface="Courier New" pitchFamily="34" charset="0"/>
+                <a:ea typeface="Courier New" pitchFamily="34" charset="-122"/>
+                <a:cs typeface="Courier New" pitchFamily="34" charset="-120"/>
+              </a:rPr>
+              <a:t>        m_driveMotor.setThrottle(speed);                          // 2. drive...</a:t>
+            </a:r>
+            <a:endParaRPr lang="en-US" sz="1300" dirty="0"/>
+          </a:p>
+          <a:p>
+            <a:pPr indent="0" marL="0">
+              <a:lnSpc>
+                <a:spcPct val="120000"/>
+              </a:lnSpc>
+              <a:buNone/>
+            </a:pPr>
+            <a:r>
+              <a:rPr lang="en-US" sz="1300" dirty="0">
+                <a:solidFill>
+                  <a:srgbClr val="9EF01A"/>
+                </a:solidFill>
+                <a:latin typeface="Courier New" pitchFamily="34" charset="0"/>
+                <a:ea typeface="Courier New" pitchFamily="34" charset="-122"/>
+                <a:cs typeface="Courier New" pitchFamily="34" charset="-120"/>
+              </a:rPr>
+              <a:t>        coroutine.waitUntil(() -&gt; getDistanceMeters() &gt;= meters); // 3. ...wait</a:t>
+            </a:r>
+            <a:endParaRPr lang="en-US" sz="1300" dirty="0"/>
+          </a:p>
+          <a:p>
+            <a:pPr indent="0" marL="0">
+              <a:lnSpc>
+                <a:spcPct val="120000"/>
+              </a:lnSpc>
+              <a:buNone/>
+            </a:pPr>
+            <a:r>
+              <a:rPr lang="en-US" sz="1300" dirty="0">
+                <a:solidFill>
+                  <a:srgbClr val="D7E3F4"/>
+                </a:solidFill>
+                <a:latin typeface="Courier New" pitchFamily="34" charset="0"/>
+                <a:ea typeface="Courier New" pitchFamily="34" charset="-122"/>
+                <a:cs typeface="Courier New" pitchFamily="34" charset="-120"/>
+              </a:rPr>
+              <a:t>        m_driveMotor.setThrottle(0);                              // 4. stop</a:t>
+            </a:r>
+            <a:endParaRPr lang="en-US" sz="1300" dirty="0"/>
+          </a:p>
+          <a:p>
+            <a:pPr indent="0" marL="0">
+              <a:lnSpc>
+                <a:spcPct val="120000"/>
+              </a:lnSpc>
+              <a:buNone/>
+            </a:pPr>
+            <a:r>
+              <a:rPr lang="en-US" sz="1300" dirty="0">
+                <a:solidFill>
+                  <a:srgbClr val="D7E3F4"/>
+                </a:solidFill>
+                <a:latin typeface="Courier New" pitchFamily="34" charset="0"/>
+                <a:ea typeface="Courier New" pitchFamily="34" charset="-122"/>
+                <a:cs typeface="Courier New" pitchFamily="34" charset="-120"/>
+              </a:rPr>
+              <a:t>      })</a:t>
+            </a:r>
+            <a:endParaRPr lang="en-US" sz="1300" dirty="0"/>
+          </a:p>
+          <a:p>
+            <a:pPr indent="0" marL="0">
+              <a:lnSpc>
+                <a:spcPct val="120000"/>
+              </a:lnSpc>
+              <a:buNone/>
+            </a:pPr>
+            <a:r>
+              <a:rPr lang="en-US" sz="1300" dirty="0">
+                <a:solidFill>
+                  <a:srgbClr val="9EF01A"/>
+                </a:solidFill>
+                <a:latin typeface="Courier New" pitchFamily="34" charset="0"/>
+                <a:ea typeface="Courier New" pitchFamily="34" charset="-122"/>
+                <a:cs typeface="Courier New" pitchFamily="34" charset="-120"/>
+              </a:rPr>
+              <a:t>      .whenCanceled(() -&gt; m_driveMotor.setThrottle(0))</a:t>
+            </a:r>
+            <a:endParaRPr lang="en-US" sz="1300" dirty="0"/>
+          </a:p>
+          <a:p>
+            <a:pPr indent="0" marL="0">
+              <a:lnSpc>
+                <a:spcPct val="120000"/>
+              </a:lnSpc>
+              <a:buNone/>
+            </a:pPr>
+            <a:r>
+              <a:rPr lang="en-US" sz="1300" dirty="0">
+                <a:solidFill>
+                  <a:srgbClr val="9EF01A"/>
+                </a:solidFill>
+                <a:latin typeface="Courier New" pitchFamily="34" charset="0"/>
+                <a:ea typeface="Courier New" pitchFamily="34" charset="-122"/>
+                <a:cs typeface="Courier New" pitchFamily="34" charset="-120"/>
+              </a:rPr>
+              <a:t>      .named("Drive Distance");</a:t>
+            </a:r>
+            <a:endParaRPr lang="en-US" sz="1300" dirty="0"/>
+          </a:p>
+          <a:p>
+            <a:pPr indent="0" marL="0">
+              <a:lnSpc>
+                <a:spcPct val="120000"/>
+              </a:lnSpc>
+              <a:buNone/>
+            </a:pPr>
+            <a:r>
+              <a:rPr lang="en-US" sz="1300" dirty="0">
+                <a:solidFill>
+                  <a:srgbClr val="D7E3F4"/>
+                </a:solidFill>
+                <a:latin typeface="Courier New" pitchFamily="34" charset="0"/>
+                <a:ea typeface="Courier New" pitchFamily="34" charset="-122"/>
+                <a:cs typeface="Courier New" pitchFamily="34" charset="-120"/>
+              </a:rPr>
+              <a:t>}</a:t>
+            </a:r>
+            <a:endParaRPr lang="en-US" sz="1300" dirty="0"/>
+          </a:p>
+        </p:txBody>
+      </p:sp>
+      <p:sp>
+        <p:nvSpPr>
+          <p:cNvPr id="12" name="Text 9"/>
+          <p:cNvSpPr/>
+          <p:nvPr/>
+        </p:nvSpPr>
+        <p:spPr>
+          <a:xfrm>
+            <a:off x="640080" y="6446520"/>
+            <a:ext cx="8229600" cy="365760"/>
+          </a:xfrm>
+          <a:prstGeom prst="rect">
+            <a:avLst/>
+          </a:prstGeom>
+          <a:noFill/>
+          <a:ln/>
+        </p:spPr>
+        <p:txBody>
+          <a:bodyPr wrap="square" lIns="0" tIns="0" rIns="0" bIns="0" rtlCol="0" anchor="ctr"/>
+          <a:lstStyle/>
+          <a:p>
+            <a:pPr indent="0" marL="0">
+              <a:buNone/>
+            </a:pPr>
+            <a:r>
+              <a:rPr lang="en-US" sz="2000" spc="100" kern="0" dirty="0">
+                <a:solidFill>
+                  <a:srgbClr val="5B6B84"/>
                 </a:solidFill>
                 <a:latin typeface="Calibri" pitchFamily="34" charset="0"/>
                 <a:ea typeface="Calibri" pitchFamily="34" charset="-122"/>
                 <a:cs typeface="Calibri" pitchFamily="34" charset="-120"/>
               </a:rPr>
-              <a:t>The condition is a lambda that answers true or false, checked every tick — the same trick as Lesson 2's DoubleSupplier, but yes/no instead of a number. Once it's true, the next line runs.</a:t>
+              <a:t>LEARN JAVA + ROBOT PROGRAMMING · DISTANCE &amp; COMMANDS</a:t>
             </a:r>
             <a:endParaRPr lang="en-US" sz="2000" dirty="0"/>
           </a:p>
@@ -7903,36 +9033,14 @@
       </p:sp>
       <p:sp>
         <p:nvSpPr>
-          <p:cNvPr id="10" name="Shape 7"/>
-          <p:cNvSpPr/>
-          <p:nvPr/>
-        </p:nvSpPr>
-        <p:spPr>
-          <a:xfrm>
-            <a:off x="6172200" y="1600200"/>
-            <a:ext cx="5349240" cy="4251960"/>
-          </a:xfrm>
-          <a:prstGeom prst="roundRect">
-            <a:avLst>
-              <a:gd name="adj" fmla="val 2151"/>
-            </a:avLst>
-          </a:prstGeom>
-          <a:solidFill>
-            <a:srgbClr val="0B1F3A"/>
-          </a:solidFill>
-          <a:ln/>
-        </p:spPr>
-      </p:sp>
-      <p:sp>
-        <p:nvSpPr>
-          <p:cNvPr id="11" name="Text 8"/>
-          <p:cNvSpPr/>
-          <p:nvPr/>
-        </p:nvSpPr>
-        <p:spPr>
-          <a:xfrm>
-            <a:off x="6446520" y="1874520"/>
-            <a:ext cx="4800600" cy="365760"/>
+          <p:cNvPr id="13" name="Text 10"/>
+          <p:cNvSpPr/>
+          <p:nvPr/>
+        </p:nvSpPr>
+        <p:spPr>
+          <a:xfrm>
+            <a:off x="11002975" y="6446520"/>
+            <a:ext cx="548640" cy="365760"/>
           </a:xfrm>
           <a:prstGeom prst="rect">
             <a:avLst/>
@@ -7944,180 +9052,18 @@
           <a:bodyPr wrap="square" lIns="0" tIns="0" rIns="0" bIns="0" rtlCol="0" anchor="ctr"/>
           <a:lstStyle/>
           <a:p>
-            <a:pPr indent="0" marL="0">
-              <a:buNone/>
-            </a:pPr>
-            <a:r>
-              <a:rPr lang="en-US" sz="2000" b="1" spc="50" kern="0" dirty="0">
-                <a:solidFill>
-                  <a:srgbClr val="1B9AAA"/>
+            <a:pPr algn="r" indent="0" marL="0">
+              <a:buNone/>
+            </a:pPr>
+            <a:r>
+              <a:rPr lang="en-US" sz="2000" dirty="0">
+                <a:solidFill>
+                  <a:srgbClr val="5B6B84"/>
                 </a:solidFill>
                 <a:latin typeface="Calibri" pitchFamily="34" charset="0"/>
                 <a:ea typeface="Calibri" pitchFamily="34" charset="-122"/>
                 <a:cs typeface="Calibri" pitchFamily="34" charset="-120"/>
               </a:rPr>
-              <a:t>THE WHOLE SHAPE</a:t>
-            </a:r>
-            <a:endParaRPr lang="en-US" sz="2000" dirty="0"/>
-          </a:p>
-        </p:txBody>
-      </p:sp>
-      <p:sp>
-        <p:nvSpPr>
-          <p:cNvPr id="12" name="Text 9"/>
-          <p:cNvSpPr/>
-          <p:nvPr/>
-        </p:nvSpPr>
-        <p:spPr>
-          <a:xfrm>
-            <a:off x="6446520" y="2331720"/>
-            <a:ext cx="4800600" cy="895350"/>
-          </a:xfrm>
-          <a:prstGeom prst="rect">
-            <a:avLst/>
-          </a:prstGeom>
-          <a:noFill/>
-          <a:ln/>
-        </p:spPr>
-        <p:txBody>
-          <a:bodyPr wrap="square" lIns="0" tIns="0" rIns="0" bIns="0" rtlCol="0" anchor="t"/>
-          <a:lstStyle/>
-          <a:p>
-            <a:pPr indent="0" marL="0">
-              <a:lnSpc>
-                <a:spcPct val="120000"/>
-              </a:lnSpc>
-              <a:buNone/>
-            </a:pPr>
-            <a:r>
-              <a:rPr lang="en-US" sz="2100" b="1" dirty="0">
-                <a:solidFill>
-                  <a:srgbClr val="FFFFFF"/>
-                </a:solidFill>
-                <a:latin typeface="Cambria" pitchFamily="34" charset="0"/>
-                <a:ea typeface="Cambria" pitchFamily="34" charset="-122"/>
-                <a:cs typeface="Cambria" pitchFamily="34" charset="-120"/>
-              </a:rPr>
-              <a:t>Set up, work, wait, clean up — one method, four lines.</a:t>
-            </a:r>
-            <a:endParaRPr lang="en-US" sz="2100" dirty="0"/>
-          </a:p>
-        </p:txBody>
-      </p:sp>
-      <p:sp>
-        <p:nvSpPr>
-          <p:cNvPr id="13" name="Text 10"/>
-          <p:cNvSpPr/>
-          <p:nvPr/>
-        </p:nvSpPr>
-        <p:spPr>
-          <a:xfrm>
-            <a:off x="6446520" y="3227070"/>
-            <a:ext cx="4800600" cy="2350770"/>
-          </a:xfrm>
-          <a:prstGeom prst="rect">
-            <a:avLst/>
-          </a:prstGeom>
-          <a:noFill/>
-          <a:ln/>
-        </p:spPr>
-        <p:txBody>
-          <a:bodyPr wrap="square" lIns="0" tIns="0" rIns="0" bIns="0" rtlCol="0" anchor="t"/>
-          <a:lstStyle/>
-          <a:p>
-            <a:pPr indent="0" marL="0">
-              <a:lnSpc>
-                <a:spcPct val="125000"/>
-              </a:lnSpc>
-              <a:buNone/>
-            </a:pPr>
-            <a:r>
-              <a:rPr lang="en-US" sz="2000" dirty="0">
-                <a:solidFill>
-                  <a:srgbClr val="CADCE8"/>
-                </a:solidFill>
-                <a:latin typeface="Calibri" pitchFamily="34" charset="0"/>
-                <a:ea typeface="Calibri" pitchFamily="34" charset="-122"/>
-                <a:cs typeface="Calibri" pitchFamily="34" charset="-120"/>
-              </a:rPr>
-              <a:t>"Do this, then wait, then do that" is just Java's normal control flow now. No separate decorators needed — you'll write this shape constantly from here on.</a:t>
-            </a:r>
-            <a:endParaRPr lang="en-US" sz="2000" dirty="0"/>
-          </a:p>
-        </p:txBody>
-      </p:sp>
-      <p:sp>
-        <p:nvSpPr>
-          <p:cNvPr id="14" name="Text 11"/>
-          <p:cNvSpPr/>
-          <p:nvPr/>
-        </p:nvSpPr>
-        <p:spPr>
-          <a:xfrm>
-            <a:off x="640080" y="6446520"/>
-            <a:ext cx="8229600" cy="365760"/>
-          </a:xfrm>
-          <a:prstGeom prst="rect">
-            <a:avLst/>
-          </a:prstGeom>
-          <a:noFill/>
-          <a:ln/>
-        </p:spPr>
-        <p:txBody>
-          <a:bodyPr wrap="square" lIns="0" tIns="0" rIns="0" bIns="0" rtlCol="0" anchor="ctr"/>
-          <a:lstStyle/>
-          <a:p>
-            <a:pPr indent="0" marL="0">
-              <a:buNone/>
-            </a:pPr>
-            <a:r>
-              <a:rPr lang="en-US" sz="2000" spc="100" kern="0" dirty="0">
-                <a:solidFill>
-                  <a:srgbClr val="5B6B84"/>
-                </a:solidFill>
-                <a:latin typeface="Calibri" pitchFamily="34" charset="0"/>
-                <a:ea typeface="Calibri" pitchFamily="34" charset="-122"/>
-                <a:cs typeface="Calibri" pitchFamily="34" charset="-120"/>
-              </a:rPr>
-              <a:t>LEARN JAVA + ROBOT PROGRAMMING · DISTANCE &amp; COMMANDS</a:t>
-            </a:r>
-            <a:endParaRPr lang="en-US" sz="2000" dirty="0"/>
-          </a:p>
-        </p:txBody>
-      </p:sp>
-      <p:sp>
-        <p:nvSpPr>
-          <p:cNvPr id="15" name="Text 12"/>
-          <p:cNvSpPr/>
-          <p:nvPr/>
-        </p:nvSpPr>
-        <p:spPr>
-          <a:xfrm>
-            <a:off x="11002975" y="6446520"/>
-            <a:ext cx="548640" cy="365760"/>
-          </a:xfrm>
-          <a:prstGeom prst="rect">
-            <a:avLst/>
-          </a:prstGeom>
-          <a:noFill/>
-          <a:ln/>
-        </p:spPr>
-        <p:txBody>
-          <a:bodyPr wrap="square" lIns="0" tIns="0" rIns="0" bIns="0" rtlCol="0" anchor="ctr"/>
-          <a:lstStyle/>
-          <a:p>
-            <a:pPr algn="r" indent="0" marL="0">
-              <a:buNone/>
-            </a:pPr>
-            <a:r>
-              <a:rPr lang="en-US" sz="2000" dirty="0">
-                <a:solidFill>
-                  <a:srgbClr val="5B6B84"/>
-                </a:solidFill>
-                <a:latin typeface="Calibri" pitchFamily="34" charset="0"/>
-                <a:ea typeface="Calibri" pitchFamily="34" charset="-122"/>
-                <a:cs typeface="Calibri" pitchFamily="34" charset="-120"/>
-              </a:rPr>
               <a:t>8</a:t>
             </a:r>
             <a:endParaRPr lang="en-US" sz="2000" dirty="0"/>
@@ -8126,7 +9072,7 @@
       </p:sp>
       <p:pic>
         <p:nvPicPr>
-          <p:cNvPr id="16" name="Image 1" descr="/home/user/BasicRobotLessons/docs/presentations/v3/template/assets/logo/team5010-logo-onwhite.png">    </p:cNvPr>
+          <p:cNvPr id="14" name="Image 1" descr="/home/user/BasicRobotLessons/docs/presentations/v3/template/assets/logo/team5010-logo-onwhite.png">    </p:cNvPr>
           <p:cNvPicPr>
             <a:picLocks noChangeAspect="1"/>
           </p:cNvPicPr>
@@ -8162,7 +9108,7 @@
     <p:bg>
       <p:bgPr>
         <a:solidFill>
-          <a:srgbClr val="0B1F3A"/>
+          <a:srgbClr val="FFFFFF"/>
         </a:solidFill>
       </p:bgPr>
     </p:bg>
@@ -8195,14 +9141,14 @@
             <a:avLst/>
           </a:prstGeom>
           <a:solidFill>
-            <a:srgbClr val="FF5010"/>
+            <a:srgbClr val="0B1F3A"/>
           </a:solidFill>
           <a:ln/>
         </p:spPr>
       </p:sp>
       <p:pic>
         <p:nvPicPr>
-          <p:cNvPr id="3" name="Image 0" descr="/home/user/BasicRobotLessons/docs/presentations/v3/template/assets/icons/checkcircle_white.png">    </p:cNvPr>
+          <p:cNvPr id="3" name="Image 0" descr="/home/user/BasicRobotLessons/docs/presentations/v3/template/assets/icons/lightbulb_white.png">    </p:cNvPr>
           <p:cNvPicPr>
             <a:picLocks noChangeAspect="1"/>
           </p:cNvPicPr>
@@ -8249,15 +9195,15 @@
               <a:buNone/>
             </a:pPr>
             <a:r>
-              <a:rPr lang="en-US" sz="2000" b="1" spc="100" kern="0" dirty="0">
-                <a:solidFill>
-                  <a:srgbClr val="1B9AAA"/>
+              <a:rPr lang="en-US" sz="2000" b="1" spc="150" kern="0" dirty="0">
+                <a:solidFill>
+                  <a:srgbClr val="FF5010"/>
                 </a:solidFill>
                 <a:latin typeface="Calibri" pitchFamily="34" charset="0"/>
                 <a:ea typeface="Calibri" pitchFamily="34" charset="-122"/>
                 <a:cs typeface="Calibri" pitchFamily="34" charset="-120"/>
               </a:rPr>
-              <a:t>SECTION 3 · TWO DIFFERENT ENDINGS</a:t>
+              <a:t>SECTION 3 · WHAT WAITUNTIL DOES</a:t>
             </a:r>
             <a:endParaRPr lang="en-US" sz="2000" dirty="0"/>
           </a:p>
@@ -8290,13 +9236,13 @@
             <a:r>
               <a:rPr lang="en-US" sz="3000" b="1" dirty="0">
                 <a:solidFill>
-                  <a:srgbClr val="FFFFFF"/>
+                  <a:srgbClr val="13294B"/>
                 </a:solidFill>
                 <a:latin typeface="Cambria" pitchFamily="34" charset="0"/>
                 <a:ea typeface="Cambria" pitchFamily="34" charset="-122"/>
                 <a:cs typeface="Cambria" pitchFamily="34" charset="-120"/>
               </a:rPr>
-              <a:t>Finished and canceled are genuinely different events</a:t>
+              <a:t>Suspend here, checking every tick, until true</a:t>
             </a:r>
             <a:endParaRPr lang="en-US" sz="3000" dirty="0"/>
           </a:p>
@@ -8310,16 +9256,16 @@
         </p:nvSpPr>
         <p:spPr>
           <a:xfrm>
-            <a:off x="640080" y="1691640"/>
-            <a:ext cx="5349240" cy="3291840"/>
+            <a:off x="640080" y="1600200"/>
+            <a:ext cx="5349240" cy="4251960"/>
           </a:xfrm>
           <a:prstGeom prst="roundRect">
             <a:avLst>
-              <a:gd name="adj" fmla="val 3333"/>
+              <a:gd name="adj" fmla="val 2151"/>
             </a:avLst>
           </a:prstGeom>
           <a:solidFill>
-            <a:srgbClr val="132A4C"/>
+            <a:srgbClr val="F3F6FA"/>
           </a:solidFill>
           <a:ln/>
         </p:spPr>
@@ -8332,8 +9278,8 @@
         </p:nvSpPr>
         <p:spPr>
           <a:xfrm>
-            <a:off x="914400" y="1965960"/>
-            <a:ext cx="4800600" cy="548640"/>
+            <a:off x="914400" y="1874520"/>
+            <a:ext cx="4800600" cy="365760"/>
           </a:xfrm>
           <a:prstGeom prst="rect">
             <a:avLst/>
@@ -8349,30 +9295,72 @@
               <a:buNone/>
             </a:pPr>
             <a:r>
-              <a:rPr lang="en-US" sz="2600" b="1" dirty="0">
+              <a:rPr lang="en-US" sz="2000" b="1" spc="50" kern="0" dirty="0">
                 <a:solidFill>
                   <a:srgbClr val="FF5010"/>
+                </a:solidFill>
+                <a:latin typeface="Calibri" pitchFamily="34" charset="0"/>
+                <a:ea typeface="Calibri" pitchFamily="34" charset="-122"/>
+                <a:cs typeface="Calibri" pitchFamily="34" charset="-120"/>
+              </a:rPr>
+              <a:t>COROUTINE.WAITUNTIL(CONDITION)</a:t>
+            </a:r>
+            <a:endParaRPr lang="en-US" sz="2000" dirty="0"/>
+          </a:p>
+        </p:txBody>
+      </p:sp>
+      <p:sp>
+        <p:nvSpPr>
+          <p:cNvPr id="8" name="Text 5"/>
+          <p:cNvSpPr/>
+          <p:nvPr/>
+        </p:nvSpPr>
+        <p:spPr>
+          <a:xfrm>
+            <a:off x="914400" y="2331720"/>
+            <a:ext cx="4800600" cy="561975"/>
+          </a:xfrm>
+          <a:prstGeom prst="rect">
+            <a:avLst/>
+          </a:prstGeom>
+          <a:noFill/>
+          <a:ln/>
+        </p:spPr>
+        <p:txBody>
+          <a:bodyPr wrap="square" lIns="0" tIns="0" rIns="0" bIns="0" rtlCol="0" anchor="t"/>
+          <a:lstStyle/>
+          <a:p>
+            <a:pPr indent="0" marL="0">
+              <a:lnSpc>
+                <a:spcPct val="120000"/>
+              </a:lnSpc>
+              <a:buNone/>
+            </a:pPr>
+            <a:r>
+              <a:rPr lang="en-US" sz="2100" b="1" dirty="0">
+                <a:solidFill>
+                  <a:srgbClr val="13294B"/>
                 </a:solidFill>
                 <a:latin typeface="Cambria" pitchFamily="34" charset="0"/>
                 <a:ea typeface="Cambria" pitchFamily="34" charset="-122"/>
                 <a:cs typeface="Cambria" pitchFamily="34" charset="-120"/>
               </a:rPr>
-              <a:t>Finished</a:t>
-            </a:r>
-            <a:endParaRPr lang="en-US" sz="2600" dirty="0"/>
-          </a:p>
-        </p:txBody>
-      </p:sp>
-      <p:sp>
-        <p:nvSpPr>
-          <p:cNvPr id="8" name="Text 5"/>
-          <p:cNvSpPr/>
-          <p:nvPr/>
-        </p:nvSpPr>
-        <p:spPr>
-          <a:xfrm>
-            <a:off x="914400" y="2606040"/>
-            <a:ext cx="4800600" cy="2286000"/>
+              <a:t>Suspends the command right here.</a:t>
+            </a:r>
+            <a:endParaRPr lang="en-US" sz="2100" dirty="0"/>
+          </a:p>
+        </p:txBody>
+      </p:sp>
+      <p:sp>
+        <p:nvSpPr>
+          <p:cNvPr id="9" name="Text 6"/>
+          <p:cNvSpPr/>
+          <p:nvPr/>
+        </p:nvSpPr>
+        <p:spPr>
+          <a:xfrm>
+            <a:off x="914400" y="2893695"/>
+            <a:ext cx="4800600" cy="2684145"/>
           </a:xfrm>
           <a:prstGeom prst="rect">
             <a:avLst/>
@@ -8393,13 +9381,13 @@
             <a:r>
               <a:rPr lang="en-US" sz="2000" dirty="0">
                 <a:solidFill>
-                  <a:srgbClr val="D7E3F4"/>
+                  <a:srgbClr val="13294B"/>
                 </a:solidFill>
                 <a:latin typeface="Calibri" pitchFamily="34" charset="0"/>
                 <a:ea typeface="Calibri" pitchFamily="34" charset="-122"/>
                 <a:cs typeface="Calibri" pitchFamily="34" charset="-120"/>
               </a:rPr>
-              <a:t>The body ran to the end by itself. Line 4, setThrottle(0), already handled it.</a:t>
+              <a:t>The condition is a lambda that answers true or false, checked every tick — the same trick as Lesson 2's DoubleSupplier, but yes/no instead of a number. Once it's true, the next line runs.</a:t>
             </a:r>
             <a:endParaRPr lang="en-US" sz="2000" dirty="0"/>
           </a:p>
@@ -8407,36 +9395,36 @@
       </p:sp>
       <p:sp>
         <p:nvSpPr>
-          <p:cNvPr id="9" name="Shape 6"/>
-          <p:cNvSpPr/>
-          <p:nvPr/>
-        </p:nvSpPr>
-        <p:spPr>
-          <a:xfrm>
-            <a:off x="6172200" y="1691640"/>
-            <a:ext cx="5349240" cy="3291840"/>
+          <p:cNvPr id="10" name="Shape 7"/>
+          <p:cNvSpPr/>
+          <p:nvPr/>
+        </p:nvSpPr>
+        <p:spPr>
+          <a:xfrm>
+            <a:off x="6172200" y="1600200"/>
+            <a:ext cx="5349240" cy="4251960"/>
           </a:xfrm>
           <a:prstGeom prst="roundRect">
             <a:avLst>
-              <a:gd name="adj" fmla="val 3333"/>
+              <a:gd name="adj" fmla="val 2151"/>
             </a:avLst>
           </a:prstGeom>
           <a:solidFill>
-            <a:srgbClr val="132A4C"/>
+            <a:srgbClr val="0B1F3A"/>
           </a:solidFill>
           <a:ln/>
         </p:spPr>
       </p:sp>
       <p:sp>
         <p:nvSpPr>
-          <p:cNvPr id="10" name="Text 7"/>
-          <p:cNvSpPr/>
-          <p:nvPr/>
-        </p:nvSpPr>
-        <p:spPr>
-          <a:xfrm>
-            <a:off x="6446520" y="1965960"/>
-            <a:ext cx="4800600" cy="548640"/>
+          <p:cNvPr id="11" name="Text 8"/>
+          <p:cNvSpPr/>
+          <p:nvPr/>
+        </p:nvSpPr>
+        <p:spPr>
+          <a:xfrm>
+            <a:off x="6446520" y="1874520"/>
+            <a:ext cx="4800600" cy="365760"/>
           </a:xfrm>
           <a:prstGeom prst="rect">
             <a:avLst/>
@@ -8452,30 +9440,72 @@
               <a:buNone/>
             </a:pPr>
             <a:r>
-              <a:rPr lang="en-US" sz="2600" b="1" dirty="0">
-                <a:solidFill>
-                  <a:srgbClr val="FF5010"/>
+              <a:rPr lang="en-US" sz="2000" b="1" spc="50" kern="0" dirty="0">
+                <a:solidFill>
+                  <a:srgbClr val="1B9AAA"/>
+                </a:solidFill>
+                <a:latin typeface="Calibri" pitchFamily="34" charset="0"/>
+                <a:ea typeface="Calibri" pitchFamily="34" charset="-122"/>
+                <a:cs typeface="Calibri" pitchFamily="34" charset="-120"/>
+              </a:rPr>
+              <a:t>THE WHOLE SHAPE</a:t>
+            </a:r>
+            <a:endParaRPr lang="en-US" sz="2000" dirty="0"/>
+          </a:p>
+        </p:txBody>
+      </p:sp>
+      <p:sp>
+        <p:nvSpPr>
+          <p:cNvPr id="12" name="Text 9"/>
+          <p:cNvSpPr/>
+          <p:nvPr/>
+        </p:nvSpPr>
+        <p:spPr>
+          <a:xfrm>
+            <a:off x="6446520" y="2331720"/>
+            <a:ext cx="4800600" cy="895350"/>
+          </a:xfrm>
+          <a:prstGeom prst="rect">
+            <a:avLst/>
+          </a:prstGeom>
+          <a:noFill/>
+          <a:ln/>
+        </p:spPr>
+        <p:txBody>
+          <a:bodyPr wrap="square" lIns="0" tIns="0" rIns="0" bIns="0" rtlCol="0" anchor="t"/>
+          <a:lstStyle/>
+          <a:p>
+            <a:pPr indent="0" marL="0">
+              <a:lnSpc>
+                <a:spcPct val="120000"/>
+              </a:lnSpc>
+              <a:buNone/>
+            </a:pPr>
+            <a:r>
+              <a:rPr lang="en-US" sz="2100" b="1" dirty="0">
+                <a:solidFill>
+                  <a:srgbClr val="FFFFFF"/>
                 </a:solidFill>
                 <a:latin typeface="Cambria" pitchFamily="34" charset="0"/>
                 <a:ea typeface="Cambria" pitchFamily="34" charset="-122"/>
                 <a:cs typeface="Cambria" pitchFamily="34" charset="-120"/>
               </a:rPr>
-              <a:t>Canceled</a:t>
-            </a:r>
-            <a:endParaRPr lang="en-US" sz="2600" dirty="0"/>
-          </a:p>
-        </p:txBody>
-      </p:sp>
-      <p:sp>
-        <p:nvSpPr>
-          <p:cNvPr id="11" name="Text 8"/>
-          <p:cNvSpPr/>
-          <p:nvPr/>
-        </p:nvSpPr>
-        <p:spPr>
-          <a:xfrm>
-            <a:off x="6446520" y="2606040"/>
-            <a:ext cx="4800600" cy="2286000"/>
+              <a:t>Set up, work, wait, clean up — one method, four lines.</a:t>
+            </a:r>
+            <a:endParaRPr lang="en-US" sz="2100" dirty="0"/>
+          </a:p>
+        </p:txBody>
+      </p:sp>
+      <p:sp>
+        <p:nvSpPr>
+          <p:cNvPr id="13" name="Text 10"/>
+          <p:cNvSpPr/>
+          <p:nvPr/>
+        </p:nvSpPr>
+        <p:spPr>
+          <a:xfrm>
+            <a:off x="6446520" y="3227070"/>
+            <a:ext cx="4800600" cy="2350770"/>
           </a:xfrm>
           <a:prstGeom prst="rect">
             <a:avLst/>
@@ -8496,13 +9526,13 @@
             <a:r>
               <a:rPr lang="en-US" sz="2000" dirty="0">
                 <a:solidFill>
-                  <a:srgbClr val="D7E3F4"/>
+                  <a:srgbClr val="CADCE8"/>
                 </a:solidFill>
                 <a:latin typeface="Calibri" pitchFamily="34" charset="0"/>
                 <a:ea typeface="Calibri" pitchFamily="34" charset="-122"/>
                 <a:cs typeface="Calibri" pitchFamily="34" charset="-120"/>
               </a:rPr>
-              <a:t>Something else took the module away first — the body's own line 4 never gets to run. That's what .whenCanceled(...) is for.</a:t>
+              <a:t>"Do this, then wait, then do that" is just Java's normal control flow now. No separate decorators needed — you'll write this shape constantly from here on.</a:t>
             </a:r>
             <a:endParaRPr lang="en-US" sz="2000" dirty="0"/>
           </a:p>
@@ -8510,49 +9540,7 @@
       </p:sp>
       <p:sp>
         <p:nvSpPr>
-          <p:cNvPr id="12" name="Text 9"/>
-          <p:cNvSpPr/>
-          <p:nvPr/>
-        </p:nvSpPr>
-        <p:spPr>
-          <a:xfrm>
-            <a:off x="640080" y="5166360"/>
-            <a:ext cx="10881360" cy="1051560"/>
-          </a:xfrm>
-          <a:prstGeom prst="rect">
-            <a:avLst/>
-          </a:prstGeom>
-          <a:noFill/>
-          <a:ln/>
-        </p:spPr>
-        <p:txBody>
-          <a:bodyPr wrap="square" lIns="0" tIns="0" rIns="0" bIns="0" rtlCol="0" anchor="t"/>
-          <a:lstStyle/>
-          <a:p>
-            <a:pPr indent="0" marL="0">
-              <a:lnSpc>
-                <a:spcPct val="125000"/>
-              </a:lnSpc>
-              <a:buNone/>
-            </a:pPr>
-            <a:r>
-              <a:rPr lang="en-US" sz="2000" i="1" dirty="0">
-                <a:solidFill>
-                  <a:srgbClr val="CADCE8"/>
-                </a:solidFill>
-                <a:latin typeface="Cambria" pitchFamily="34" charset="0"/>
-                <a:ea typeface="Cambria" pitchFamily="34" charset="-122"/>
-                <a:cs typeface="Cambria" pitchFamily="34" charset="-120"/>
-              </a:rPr>
-              <a:t>Every earlier command only had one ending. driveDistance is the first with two doors the motor can sneak out of — miss either cleanup, and it keeps spinning.</a:t>
-            </a:r>
-            <a:endParaRPr lang="en-US" sz="2000" dirty="0"/>
-          </a:p>
-        </p:txBody>
-      </p:sp>
-      <p:sp>
-        <p:nvSpPr>
-          <p:cNvPr id="13" name="Text 10"/>
+          <p:cNvPr id="14" name="Text 11"/>
           <p:cNvSpPr/>
           <p:nvPr/>
         </p:nvSpPr>
@@ -8577,7 +9565,7 @@
             <a:r>
               <a:rPr lang="en-US" sz="2000" spc="100" kern="0" dirty="0">
                 <a:solidFill>
-                  <a:srgbClr val="7A93B8"/>
+                  <a:srgbClr val="5B6B84"/>
                 </a:solidFill>
                 <a:latin typeface="Calibri" pitchFamily="34" charset="0"/>
                 <a:ea typeface="Calibri" pitchFamily="34" charset="-122"/>
@@ -8591,7 +9579,7 @@
       </p:sp>
       <p:sp>
         <p:nvSpPr>
-          <p:cNvPr id="14" name="Text 11"/>
+          <p:cNvPr id="15" name="Text 12"/>
           <p:cNvSpPr/>
           <p:nvPr/>
         </p:nvSpPr>
@@ -8616,7 +9604,7 @@
             <a:r>
               <a:rPr lang="en-US" sz="2000" dirty="0">
                 <a:solidFill>
-                  <a:srgbClr val="7A93B8"/>
+                  <a:srgbClr val="5B6B84"/>
                 </a:solidFill>
                 <a:latin typeface="Calibri" pitchFamily="34" charset="0"/>
                 <a:ea typeface="Calibri" pitchFamily="34" charset="-122"/>
@@ -8630,7 +9618,7 @@
       </p:sp>
       <p:pic>
         <p:nvPicPr>
-          <p:cNvPr id="15" name="Image 1" descr="/home/user/BasicRobotLessons/docs/presentations/v3/template/assets/logo/team5010-logo-onnavy.png">    </p:cNvPr>
+          <p:cNvPr id="16" name="Image 1" descr="/home/user/BasicRobotLessons/docs/presentations/v3/template/assets/logo/team5010-logo-onwhite.png">    </p:cNvPr>
           <p:cNvPicPr>
             <a:picLocks noChangeAspect="1"/>
           </p:cNvPicPr>

</xml_diff>